<commit_message>
Deleting Data From Session
</commit_message>
<xml_diff>
--- a/.lessons/25 Fundamental HTTP Session/4 Deleting Data From Session/1.pptx
+++ b/.lessons/25 Fundamental HTTP Session/4 Deleting Data From Session/1.pptx
@@ -8,6 +8,11 @@
     <p:sldId id="402" r:id="rId2"/>
     <p:sldId id="403" r:id="rId3"/>
     <p:sldId id="400" r:id="rId4"/>
+    <p:sldId id="404" r:id="rId5"/>
+    <p:sldId id="405" r:id="rId6"/>
+    <p:sldId id="406" r:id="rId7"/>
+    <p:sldId id="407" r:id="rId8"/>
+    <p:sldId id="408" r:id="rId9"/>
   </p:sldIdLst>
   <p:sldSz cx="12192000" cy="6858000"/>
   <p:notesSz cx="6858000" cy="9144000"/>
@@ -261,7 +266,7 @@
           <a:p>
             <a:fld id="{3E102D2E-813C-461C-9963-687A650C48C0}" type="datetimeFigureOut">
               <a:rPr lang="en-US" smtClean="0"/>
-              <a:t>5/23/2025</a:t>
+              <a:t>5/27/2025</a:t>
             </a:fld>
             <a:endParaRPr lang="en-US"/>
           </a:p>
@@ -459,7 +464,7 @@
           <a:p>
             <a:fld id="{3E102D2E-813C-461C-9963-687A650C48C0}" type="datetimeFigureOut">
               <a:rPr lang="en-US" smtClean="0"/>
-              <a:t>5/23/2025</a:t>
+              <a:t>5/27/2025</a:t>
             </a:fld>
             <a:endParaRPr lang="en-US"/>
           </a:p>
@@ -667,7 +672,7 @@
           <a:p>
             <a:fld id="{3E102D2E-813C-461C-9963-687A650C48C0}" type="datetimeFigureOut">
               <a:rPr lang="en-US" smtClean="0"/>
-              <a:t>5/23/2025</a:t>
+              <a:t>5/27/2025</a:t>
             </a:fld>
             <a:endParaRPr lang="en-US"/>
           </a:p>
@@ -865,7 +870,7 @@
           <a:p>
             <a:fld id="{3E102D2E-813C-461C-9963-687A650C48C0}" type="datetimeFigureOut">
               <a:rPr lang="en-US" smtClean="0"/>
-              <a:t>5/23/2025</a:t>
+              <a:t>5/27/2025</a:t>
             </a:fld>
             <a:endParaRPr lang="en-US"/>
           </a:p>
@@ -1140,7 +1145,7 @@
           <a:p>
             <a:fld id="{3E102D2E-813C-461C-9963-687A650C48C0}" type="datetimeFigureOut">
               <a:rPr lang="en-US" smtClean="0"/>
-              <a:t>5/23/2025</a:t>
+              <a:t>5/27/2025</a:t>
             </a:fld>
             <a:endParaRPr lang="en-US"/>
           </a:p>
@@ -1405,7 +1410,7 @@
           <a:p>
             <a:fld id="{3E102D2E-813C-461C-9963-687A650C48C0}" type="datetimeFigureOut">
               <a:rPr lang="en-US" smtClean="0"/>
-              <a:t>5/23/2025</a:t>
+              <a:t>5/27/2025</a:t>
             </a:fld>
             <a:endParaRPr lang="en-US"/>
           </a:p>
@@ -1817,7 +1822,7 @@
           <a:p>
             <a:fld id="{3E102D2E-813C-461C-9963-687A650C48C0}" type="datetimeFigureOut">
               <a:rPr lang="en-US" smtClean="0"/>
-              <a:t>5/23/2025</a:t>
+              <a:t>5/27/2025</a:t>
             </a:fld>
             <a:endParaRPr lang="en-US"/>
           </a:p>
@@ -1958,7 +1963,7 @@
           <a:p>
             <a:fld id="{3E102D2E-813C-461C-9963-687A650C48C0}" type="datetimeFigureOut">
               <a:rPr lang="en-US" smtClean="0"/>
-              <a:t>5/23/2025</a:t>
+              <a:t>5/27/2025</a:t>
             </a:fld>
             <a:endParaRPr lang="en-US"/>
           </a:p>
@@ -2071,7 +2076,7 @@
           <a:p>
             <a:fld id="{3E102D2E-813C-461C-9963-687A650C48C0}" type="datetimeFigureOut">
               <a:rPr lang="en-US" smtClean="0"/>
-              <a:t>5/23/2025</a:t>
+              <a:t>5/27/2025</a:t>
             </a:fld>
             <a:endParaRPr lang="en-US"/>
           </a:p>
@@ -2382,7 +2387,7 @@
           <a:p>
             <a:fld id="{3E102D2E-813C-461C-9963-687A650C48C0}" type="datetimeFigureOut">
               <a:rPr lang="en-US" smtClean="0"/>
-              <a:t>5/23/2025</a:t>
+              <a:t>5/27/2025</a:t>
             </a:fld>
             <a:endParaRPr lang="en-US"/>
           </a:p>
@@ -2670,7 +2675,7 @@
           <a:p>
             <a:fld id="{3E102D2E-813C-461C-9963-687A650C48C0}" type="datetimeFigureOut">
               <a:rPr lang="en-US" smtClean="0"/>
-              <a:t>5/23/2025</a:t>
+              <a:t>5/27/2025</a:t>
             </a:fld>
             <a:endParaRPr lang="en-US"/>
           </a:p>
@@ -2911,7 +2916,7 @@
           <a:p>
             <a:fld id="{3E102D2E-813C-461C-9963-687A650C48C0}" type="datetimeFigureOut">
               <a:rPr lang="en-US" smtClean="0"/>
-              <a:t>5/23/2025</a:t>
+              <a:t>5/27/2025</a:t>
             </a:fld>
             <a:endParaRPr lang="en-US"/>
           </a:p>
@@ -3349,7 +3354,7 @@
         <p:spPr>
           <a:xfrm>
             <a:off x="217714" y="255046"/>
-            <a:ext cx="11756571" cy="355354"/>
+            <a:ext cx="7606533" cy="5901039"/>
           </a:xfrm>
           <a:prstGeom prst="rect">
             <a:avLst/>
@@ -3379,11 +3384,1276 @@
                 <a:effectLst/>
                 <a:latin typeface="Arial" panose="020B0604020202020204" pitchFamily="34" charset="0"/>
               </a:rPr>
-              <a:t>.</a:t>
-            </a:r>
+              <a:t>Bu mövzuda sessiyada saxlanılan məlumatların necə silinəcəyini </a:t>
+            </a:r>
+            <a:r>
+              <a:rPr kumimoji="0" lang="az-Latn-AZ" altLang="en-US" sz="1300" b="0" i="0" u="none" strike="noStrike" cap="none" normalizeH="0" baseline="0">
+                <a:ln>
+                  <a:noFill/>
+                </a:ln>
+                <a:solidFill>
+                  <a:schemeClr val="tx1"/>
+                </a:solidFill>
+                <a:effectLst/>
+                <a:latin typeface="Arial" panose="020B0604020202020204" pitchFamily="34" charset="0"/>
+              </a:rPr>
+              <a:t>öyrənəcəyik</a:t>
+            </a:r>
+            <a:r>
+              <a:rPr kumimoji="0" lang="en-US" altLang="en-US" sz="1300" b="0" i="0" u="none" strike="noStrike" cap="none" normalizeH="0" baseline="0">
+                <a:ln>
+                  <a:noFill/>
+                </a:ln>
+                <a:solidFill>
+                  <a:schemeClr val="tx1"/>
+                </a:solidFill>
+                <a:effectLst/>
+                <a:latin typeface="Arial" panose="020B0604020202020204" pitchFamily="34" charset="0"/>
+              </a:rPr>
+              <a:t>. Laravel bizə </a:t>
+            </a:r>
+            <a:r>
+              <a:rPr kumimoji="0" lang="en-US" altLang="en-US" sz="1300" b="1" i="0" u="none" strike="noStrike" cap="none" normalizeH="0" baseline="0">
+                <a:ln>
+                  <a:noFill/>
+                </a:ln>
+                <a:solidFill>
+                  <a:schemeClr val="tx1"/>
+                </a:solidFill>
+                <a:effectLst/>
+                <a:latin typeface="Arial" panose="020B0604020202020204" pitchFamily="34" charset="0"/>
+              </a:rPr>
+              <a:t>sessiya</a:t>
+            </a:r>
+            <a:r>
+              <a:rPr kumimoji="0" lang="en-US" altLang="en-US" sz="1300" b="0" i="0" u="none" strike="noStrike" cap="none" normalizeH="0" baseline="0">
+                <a:ln>
+                  <a:noFill/>
+                </a:ln>
+                <a:solidFill>
+                  <a:schemeClr val="tx1"/>
+                </a:solidFill>
+                <a:effectLst/>
+                <a:latin typeface="Arial" panose="020B0604020202020204" pitchFamily="34" charset="0"/>
+              </a:rPr>
+              <a:t> məlumatlarını silmək üçün müxtəlif </a:t>
+            </a:r>
+            <a:r>
+              <a:rPr kumimoji="0" lang="en-US" altLang="en-US" sz="1300" b="1" i="0" u="none" strike="noStrike" cap="none" normalizeH="0" baseline="0">
+                <a:ln>
+                  <a:noFill/>
+                </a:ln>
+                <a:solidFill>
+                  <a:schemeClr val="tx1"/>
+                </a:solidFill>
+                <a:effectLst/>
+                <a:latin typeface="Arial" panose="020B0604020202020204" pitchFamily="34" charset="0"/>
+              </a:rPr>
+              <a:t>metodlar</a:t>
+            </a:r>
+            <a:r>
+              <a:rPr kumimoji="0" lang="en-US" altLang="en-US" sz="1300" b="0" i="0" u="none" strike="noStrike" cap="none" normalizeH="0" baseline="0">
+                <a:ln>
+                  <a:noFill/>
+                </a:ln>
+                <a:solidFill>
+                  <a:schemeClr val="tx1"/>
+                </a:solidFill>
+                <a:effectLst/>
+                <a:latin typeface="Arial" panose="020B0604020202020204" pitchFamily="34" charset="0"/>
+              </a:rPr>
+              <a:t> təqdim edir.</a:t>
+            </a:r>
+            <a:endParaRPr kumimoji="0" lang="az-Latn-AZ" altLang="en-US" sz="1300" b="0" i="0" u="none" strike="noStrike" cap="none" normalizeH="0" baseline="0">
+              <a:ln>
+                <a:noFill/>
+              </a:ln>
+              <a:solidFill>
+                <a:schemeClr val="tx1"/>
+              </a:solidFill>
+              <a:effectLst/>
+              <a:latin typeface="Arial" panose="020B0604020202020204" pitchFamily="34" charset="0"/>
+            </a:endParaRPr>
+          </a:p>
+          <a:p>
+            <a:pPr>
+              <a:lnSpc>
+                <a:spcPct val="150000"/>
+              </a:lnSpc>
+              <a:buNone/>
+            </a:pPr>
+            <a:endParaRPr lang="az-Latn-AZ" altLang="en-US" sz="1300">
+              <a:latin typeface="Arial" panose="020B0604020202020204" pitchFamily="34" charset="0"/>
+            </a:endParaRPr>
+          </a:p>
+          <a:p>
+            <a:pPr>
+              <a:lnSpc>
+                <a:spcPct val="150000"/>
+              </a:lnSpc>
+              <a:buNone/>
+            </a:pPr>
+            <a:endParaRPr kumimoji="0" lang="az-Latn-AZ" altLang="en-US" sz="1300" b="0" i="0" u="none" strike="noStrike" cap="none" normalizeH="0" baseline="0">
+              <a:ln>
+                <a:noFill/>
+              </a:ln>
+              <a:solidFill>
+                <a:schemeClr val="tx1"/>
+              </a:solidFill>
+              <a:effectLst/>
+              <a:latin typeface="Arial" panose="020B0604020202020204" pitchFamily="34" charset="0"/>
+            </a:endParaRPr>
+          </a:p>
+          <a:p>
+            <a:pPr>
+              <a:lnSpc>
+                <a:spcPct val="150000"/>
+              </a:lnSpc>
+              <a:buNone/>
+            </a:pPr>
+            <a:endParaRPr lang="az-Latn-AZ" altLang="en-US" sz="1300">
+              <a:latin typeface="Arial" panose="020B0604020202020204" pitchFamily="34" charset="0"/>
+            </a:endParaRPr>
+          </a:p>
+          <a:p>
+            <a:pPr>
+              <a:lnSpc>
+                <a:spcPct val="150000"/>
+              </a:lnSpc>
+              <a:buNone/>
+            </a:pPr>
+            <a:endParaRPr kumimoji="0" lang="az-Latn-AZ" altLang="en-US" sz="1300" b="0" i="0" u="none" strike="noStrike" cap="none" normalizeH="0" baseline="0">
+              <a:ln>
+                <a:noFill/>
+              </a:ln>
+              <a:solidFill>
+                <a:schemeClr val="tx1"/>
+              </a:solidFill>
+              <a:effectLst/>
+              <a:latin typeface="Arial" panose="020B0604020202020204" pitchFamily="34" charset="0"/>
+            </a:endParaRPr>
+          </a:p>
+          <a:p>
+            <a:pPr>
+              <a:lnSpc>
+                <a:spcPct val="150000"/>
+              </a:lnSpc>
+              <a:buNone/>
+            </a:pPr>
+            <a:endParaRPr lang="az-Latn-AZ" altLang="en-US" sz="1300">
+              <a:latin typeface="Arial" panose="020B0604020202020204" pitchFamily="34" charset="0"/>
+            </a:endParaRPr>
+          </a:p>
+          <a:p>
+            <a:pPr>
+              <a:lnSpc>
+                <a:spcPct val="150000"/>
+              </a:lnSpc>
+              <a:buNone/>
+            </a:pPr>
+            <a:endParaRPr kumimoji="0" lang="az-Latn-AZ" altLang="en-US" sz="1300" b="0" i="0" u="none" strike="noStrike" cap="none" normalizeH="0" baseline="0">
+              <a:ln>
+                <a:noFill/>
+              </a:ln>
+              <a:solidFill>
+                <a:schemeClr val="tx1"/>
+              </a:solidFill>
+              <a:effectLst/>
+              <a:latin typeface="Arial" panose="020B0604020202020204" pitchFamily="34" charset="0"/>
+            </a:endParaRPr>
+          </a:p>
+          <a:p>
+            <a:pPr>
+              <a:lnSpc>
+                <a:spcPct val="150000"/>
+              </a:lnSpc>
+              <a:buNone/>
+            </a:pPr>
+            <a:endParaRPr lang="az-Latn-AZ" altLang="en-US" sz="1300">
+              <a:latin typeface="Arial" panose="020B0604020202020204" pitchFamily="34" charset="0"/>
+            </a:endParaRPr>
+          </a:p>
+          <a:p>
+            <a:pPr>
+              <a:lnSpc>
+                <a:spcPct val="150000"/>
+              </a:lnSpc>
+              <a:buNone/>
+            </a:pPr>
+            <a:endParaRPr kumimoji="0" lang="az-Latn-AZ" altLang="en-US" sz="1300" b="0" i="0" u="none" strike="noStrike" cap="none" normalizeH="0" baseline="0">
+              <a:ln>
+                <a:noFill/>
+              </a:ln>
+              <a:solidFill>
+                <a:schemeClr val="tx1"/>
+              </a:solidFill>
+              <a:effectLst/>
+              <a:latin typeface="Arial" panose="020B0604020202020204" pitchFamily="34" charset="0"/>
+            </a:endParaRPr>
+          </a:p>
+          <a:p>
+            <a:pPr>
+              <a:lnSpc>
+                <a:spcPct val="150000"/>
+              </a:lnSpc>
+              <a:buNone/>
+            </a:pPr>
+            <a:endParaRPr lang="az-Latn-AZ" altLang="en-US" sz="1300">
+              <a:latin typeface="Arial" panose="020B0604020202020204" pitchFamily="34" charset="0"/>
+            </a:endParaRPr>
+          </a:p>
+          <a:p>
+            <a:pPr>
+              <a:lnSpc>
+                <a:spcPct val="150000"/>
+              </a:lnSpc>
+              <a:buNone/>
+            </a:pPr>
+            <a:endParaRPr kumimoji="0" lang="az-Latn-AZ" altLang="en-US" sz="1100" b="0" i="0" u="none" strike="noStrike" cap="none" normalizeH="0" baseline="0">
+              <a:ln>
+                <a:noFill/>
+              </a:ln>
+              <a:solidFill>
+                <a:schemeClr val="tx1"/>
+              </a:solidFill>
+              <a:effectLst/>
+              <a:latin typeface="Arial" panose="020B0604020202020204" pitchFamily="34" charset="0"/>
+            </a:endParaRPr>
+          </a:p>
+          <a:p>
+            <a:pPr>
+              <a:lnSpc>
+                <a:spcPct val="150000"/>
+              </a:lnSpc>
+              <a:buNone/>
+            </a:pPr>
+            <a:endParaRPr kumimoji="0" lang="az-Latn-AZ" altLang="en-US" sz="1100" b="0" i="0" u="none" strike="noStrike" cap="none" normalizeH="0" baseline="0">
+              <a:ln>
+                <a:noFill/>
+              </a:ln>
+              <a:solidFill>
+                <a:schemeClr val="tx1"/>
+              </a:solidFill>
+              <a:effectLst/>
+              <a:latin typeface="Arial" panose="020B0604020202020204" pitchFamily="34" charset="0"/>
+            </a:endParaRPr>
+          </a:p>
+          <a:p>
+            <a:pPr marL="171450" indent="-171450">
+              <a:lnSpc>
+                <a:spcPct val="150000"/>
+              </a:lnSpc>
+              <a:buFont typeface="Arial" panose="020B0604020202020204" pitchFamily="34" charset="0"/>
+              <a:buChar char="•"/>
+            </a:pPr>
+            <a:r>
+              <a:rPr kumimoji="0" lang="en-US" altLang="en-US" sz="1100" b="0" i="0" u="none" strike="noStrike" cap="none" normalizeH="0" baseline="0">
+                <a:ln>
+                  <a:noFill/>
+                </a:ln>
+                <a:solidFill>
+                  <a:schemeClr val="tx1"/>
+                </a:solidFill>
+                <a:effectLst/>
+                <a:latin typeface="Arial" panose="020B0604020202020204" pitchFamily="34" charset="0"/>
+              </a:rPr>
+              <a:t>Bu kod </a:t>
+            </a:r>
+            <a:r>
+              <a:rPr kumimoji="0" lang="en-US" altLang="en-US" sz="1100" b="1" i="0" u="none" strike="noStrike" cap="none" normalizeH="0" baseline="0">
+                <a:ln>
+                  <a:noFill/>
+                </a:ln>
+                <a:solidFill>
+                  <a:schemeClr val="tx1"/>
+                </a:solidFill>
+                <a:effectLst/>
+                <a:latin typeface="Arial" panose="020B0604020202020204" pitchFamily="34" charset="0"/>
+              </a:rPr>
+              <a:t>user_id </a:t>
+            </a:r>
+            <a:r>
+              <a:rPr kumimoji="0" lang="en-US" altLang="en-US" sz="1100" b="0" i="0" u="none" strike="noStrike" cap="none" normalizeH="0" baseline="0">
+                <a:ln>
+                  <a:noFill/>
+                </a:ln>
+                <a:solidFill>
+                  <a:schemeClr val="tx1"/>
+                </a:solidFill>
+                <a:effectLst/>
+                <a:latin typeface="Arial" panose="020B0604020202020204" pitchFamily="34" charset="0"/>
+              </a:rPr>
+              <a:t>adlı sessiya məlumatını silir.</a:t>
+            </a:r>
+          </a:p>
+          <a:p>
+            <a:pPr marL="171450" indent="-171450">
+              <a:lnSpc>
+                <a:spcPct val="150000"/>
+              </a:lnSpc>
+              <a:buFont typeface="Arial" panose="020B0604020202020204" pitchFamily="34" charset="0"/>
+              <a:buChar char="•"/>
+            </a:pPr>
+            <a:endParaRPr kumimoji="0" lang="en-US" altLang="en-US" sz="1100" b="0" i="0" u="none" strike="noStrike" cap="none" normalizeH="0" baseline="0">
+              <a:ln>
+                <a:noFill/>
+              </a:ln>
+              <a:solidFill>
+                <a:schemeClr val="tx1"/>
+              </a:solidFill>
+              <a:effectLst/>
+              <a:latin typeface="Arial" panose="020B0604020202020204" pitchFamily="34" charset="0"/>
+            </a:endParaRPr>
+          </a:p>
+          <a:p>
+            <a:pPr marL="171450" indent="-171450">
+              <a:lnSpc>
+                <a:spcPct val="150000"/>
+              </a:lnSpc>
+              <a:buFont typeface="Arial" panose="020B0604020202020204" pitchFamily="34" charset="0"/>
+              <a:buChar char="•"/>
+            </a:pPr>
+            <a:r>
+              <a:rPr kumimoji="0" lang="en-US" altLang="en-US" sz="1100" b="0" i="0" u="none" strike="noStrike" cap="none" normalizeH="0" baseline="0">
+                <a:ln>
+                  <a:noFill/>
+                </a:ln>
+                <a:solidFill>
+                  <a:schemeClr val="tx1"/>
+                </a:solidFill>
+                <a:effectLst/>
+                <a:latin typeface="Arial" panose="020B0604020202020204" pitchFamily="34" charset="0"/>
+              </a:rPr>
+              <a:t>Digər sessiya məlumatları saxlanılır, yalnız </a:t>
+            </a:r>
+            <a:r>
+              <a:rPr kumimoji="0" lang="en-US" altLang="en-US" sz="1100" b="1" i="0" u="none" strike="noStrike" cap="none" normalizeH="0" baseline="0">
+                <a:ln>
+                  <a:noFill/>
+                </a:ln>
+                <a:solidFill>
+                  <a:schemeClr val="tx1"/>
+                </a:solidFill>
+                <a:effectLst/>
+                <a:latin typeface="Arial" panose="020B0604020202020204" pitchFamily="34" charset="0"/>
+              </a:rPr>
+              <a:t>user_id </a:t>
+            </a:r>
+            <a:r>
+              <a:rPr kumimoji="0" lang="en-US" altLang="en-US" sz="1100" b="0" i="0" u="none" strike="noStrike" cap="none" normalizeH="0" baseline="0">
+                <a:ln>
+                  <a:noFill/>
+                </a:ln>
+                <a:solidFill>
+                  <a:schemeClr val="tx1"/>
+                </a:solidFill>
+                <a:effectLst/>
+                <a:latin typeface="Arial" panose="020B0604020202020204" pitchFamily="34" charset="0"/>
+              </a:rPr>
+              <a:t>silinir.</a:t>
+            </a:r>
+          </a:p>
+          <a:p>
+            <a:pPr marL="171450" indent="-171450">
+              <a:lnSpc>
+                <a:spcPct val="150000"/>
+              </a:lnSpc>
+              <a:buFont typeface="Arial" panose="020B0604020202020204" pitchFamily="34" charset="0"/>
+              <a:buChar char="•"/>
+            </a:pPr>
+            <a:endParaRPr kumimoji="0" lang="en-US" altLang="en-US" sz="1100" b="0" i="0" u="none" strike="noStrike" cap="none" normalizeH="0" baseline="0">
+              <a:ln>
+                <a:noFill/>
+              </a:ln>
+              <a:solidFill>
+                <a:schemeClr val="tx1"/>
+              </a:solidFill>
+              <a:effectLst/>
+              <a:latin typeface="Arial" panose="020B0604020202020204" pitchFamily="34" charset="0"/>
+            </a:endParaRPr>
+          </a:p>
+          <a:p>
+            <a:pPr marL="171450" indent="-171450">
+              <a:lnSpc>
+                <a:spcPct val="150000"/>
+              </a:lnSpc>
+              <a:buFont typeface="Arial" panose="020B0604020202020204" pitchFamily="34" charset="0"/>
+              <a:buChar char="•"/>
+            </a:pPr>
+            <a:r>
+              <a:rPr kumimoji="0" lang="en-US" altLang="en-US" sz="1100" b="1" i="0" u="none" strike="noStrike" cap="none" normalizeH="0" baseline="0">
+                <a:ln>
+                  <a:noFill/>
+                </a:ln>
+                <a:solidFill>
+                  <a:schemeClr val="tx1"/>
+                </a:solidFill>
+                <a:effectLst/>
+                <a:latin typeface="Arial" panose="020B0604020202020204" pitchFamily="34" charset="0"/>
+              </a:rPr>
+              <a:t>forget() </a:t>
+            </a:r>
+            <a:r>
+              <a:rPr kumimoji="0" lang="en-US" altLang="en-US" sz="1100" b="0" i="0" u="none" strike="noStrike" cap="none" normalizeH="0" baseline="0">
+                <a:ln>
+                  <a:noFill/>
+                </a:ln>
+                <a:solidFill>
+                  <a:schemeClr val="tx1"/>
+                </a:solidFill>
+                <a:effectLst/>
+                <a:latin typeface="Arial" panose="020B0604020202020204" pitchFamily="34" charset="0"/>
+              </a:rPr>
+              <a:t>metodu yalnız açarı silir, sessiyanın özü qalır.</a:t>
+            </a:r>
+            <a:endParaRPr kumimoji="0" lang="az-Latn-AZ" altLang="en-US" sz="1100" b="0" i="0" u="none" strike="noStrike" cap="none" normalizeH="0" baseline="0">
+              <a:ln>
+                <a:noFill/>
+              </a:ln>
+              <a:solidFill>
+                <a:schemeClr val="tx1"/>
+              </a:solidFill>
+              <a:effectLst/>
+              <a:latin typeface="Arial" panose="020B0604020202020204" pitchFamily="34" charset="0"/>
+            </a:endParaRPr>
+          </a:p>
+          <a:p>
+            <a:pPr>
+              <a:lnSpc>
+                <a:spcPct val="150000"/>
+              </a:lnSpc>
+              <a:buNone/>
+            </a:pPr>
+            <a:endParaRPr lang="az-Latn-AZ" altLang="en-US" sz="1100">
+              <a:latin typeface="Arial" panose="020B0604020202020204" pitchFamily="34" charset="0"/>
+            </a:endParaRPr>
+          </a:p>
+          <a:p>
+            <a:pPr>
+              <a:lnSpc>
+                <a:spcPct val="150000"/>
+              </a:lnSpc>
+              <a:buNone/>
+            </a:pPr>
+            <a:endParaRPr kumimoji="0" lang="az-Latn-AZ" altLang="en-US" sz="1100" b="0" i="0" u="none" strike="noStrike" cap="none" normalizeH="0" baseline="0">
+              <a:ln>
+                <a:noFill/>
+              </a:ln>
+              <a:solidFill>
+                <a:schemeClr val="tx1"/>
+              </a:solidFill>
+              <a:effectLst/>
+              <a:latin typeface="Arial" panose="020B0604020202020204" pitchFamily="34" charset="0"/>
+            </a:endParaRPr>
+          </a:p>
+          <a:p>
+            <a:pPr>
+              <a:lnSpc>
+                <a:spcPct val="150000"/>
+              </a:lnSpc>
+              <a:buNone/>
+            </a:pPr>
+            <a:endParaRPr kumimoji="0" lang="en-US" altLang="en-US" sz="1100" b="0" i="0" u="none" strike="noStrike" cap="none" normalizeH="0" baseline="0">
+              <a:ln>
+                <a:noFill/>
+              </a:ln>
+              <a:solidFill>
+                <a:schemeClr val="tx1"/>
+              </a:solidFill>
+              <a:effectLst/>
+              <a:latin typeface="Arial" panose="020B0604020202020204" pitchFamily="34" charset="0"/>
+            </a:endParaRPr>
           </a:p>
         </p:txBody>
       </p:sp>
+      <p:pic>
+        <p:nvPicPr>
+          <p:cNvPr id="4" name="Picture 3">
+            <a:extLst>
+              <a:ext uri="{FF2B5EF4-FFF2-40B4-BE49-F238E27FC236}">
+                <a16:creationId xmlns:a16="http://schemas.microsoft.com/office/drawing/2014/main" id="{D0ED71D0-377B-AFDC-380F-5D364168C141}"/>
+              </a:ext>
+            </a:extLst>
+          </p:cNvPr>
+          <p:cNvPicPr>
+            <a:picLocks noChangeAspect="1"/>
+          </p:cNvPicPr>
+          <p:nvPr/>
+        </p:nvPicPr>
+        <p:blipFill>
+          <a:blip r:embed="rId2"/>
+          <a:stretch>
+            <a:fillRect/>
+          </a:stretch>
+        </p:blipFill>
+        <p:spPr>
+          <a:xfrm>
+            <a:off x="7944255" y="0"/>
+            <a:ext cx="4247745" cy="6858000"/>
+          </a:xfrm>
+          <a:prstGeom prst="rect">
+            <a:avLst/>
+          </a:prstGeom>
+        </p:spPr>
+      </p:pic>
+      <p:grpSp>
+        <p:nvGrpSpPr>
+          <p:cNvPr id="10" name="Group 9">
+            <a:extLst>
+              <a:ext uri="{FF2B5EF4-FFF2-40B4-BE49-F238E27FC236}">
+                <a16:creationId xmlns:a16="http://schemas.microsoft.com/office/drawing/2014/main" id="{38DB2E4D-AFF6-E88B-69F9-D4BE360D8F58}"/>
+              </a:ext>
+            </a:extLst>
+          </p:cNvPr>
+          <p:cNvGrpSpPr/>
+          <p:nvPr/>
+        </p:nvGrpSpPr>
+        <p:grpSpPr>
+          <a:xfrm>
+            <a:off x="4247746" y="3827283"/>
+            <a:ext cx="3448292" cy="2870462"/>
+            <a:chOff x="3581197" y="3362673"/>
+            <a:chExt cx="4030000" cy="3240280"/>
+          </a:xfrm>
+        </p:grpSpPr>
+        <p:pic>
+          <p:nvPicPr>
+            <p:cNvPr id="6" name="Picture 5">
+              <a:extLst>
+                <a:ext uri="{FF2B5EF4-FFF2-40B4-BE49-F238E27FC236}">
+                  <a16:creationId xmlns:a16="http://schemas.microsoft.com/office/drawing/2014/main" id="{C429764C-7C87-E5CB-D7D9-421598377653}"/>
+                </a:ext>
+              </a:extLst>
+            </p:cNvPr>
+            <p:cNvPicPr>
+              <a:picLocks noChangeAspect="1"/>
+            </p:cNvPicPr>
+            <p:nvPr/>
+          </p:nvPicPr>
+          <p:blipFill>
+            <a:blip r:embed="rId3"/>
+            <a:stretch>
+              <a:fillRect/>
+            </a:stretch>
+          </p:blipFill>
+          <p:spPr>
+            <a:xfrm>
+              <a:off x="3581560" y="3362673"/>
+              <a:ext cx="4029637" cy="743054"/>
+            </a:xfrm>
+            <a:prstGeom prst="rect">
+              <a:avLst/>
+            </a:prstGeom>
+            <a:ln w="38100" cap="sq">
+              <a:solidFill>
+                <a:srgbClr val="000000"/>
+              </a:solidFill>
+              <a:prstDash val="solid"/>
+              <a:miter lim="800000"/>
+            </a:ln>
+            <a:effectLst>
+              <a:outerShdw blurRad="50800" dist="38100" dir="2700000" algn="tl" rotWithShape="0">
+                <a:srgbClr val="000000">
+                  <a:alpha val="43000"/>
+                </a:srgbClr>
+              </a:outerShdw>
+            </a:effectLst>
+          </p:spPr>
+        </p:pic>
+        <p:pic>
+          <p:nvPicPr>
+            <p:cNvPr id="8" name="Picture 7">
+              <a:extLst>
+                <a:ext uri="{FF2B5EF4-FFF2-40B4-BE49-F238E27FC236}">
+                  <a16:creationId xmlns:a16="http://schemas.microsoft.com/office/drawing/2014/main" id="{A068064C-18DF-83D9-F00E-3474A1D449E6}"/>
+                </a:ext>
+              </a:extLst>
+            </p:cNvPr>
+            <p:cNvPicPr>
+              <a:picLocks noChangeAspect="1"/>
+            </p:cNvPicPr>
+            <p:nvPr/>
+          </p:nvPicPr>
+          <p:blipFill>
+            <a:blip r:embed="rId4"/>
+            <a:stretch>
+              <a:fillRect/>
+            </a:stretch>
+          </p:blipFill>
+          <p:spPr>
+            <a:xfrm>
+              <a:off x="3581197" y="4623328"/>
+              <a:ext cx="4029638" cy="1979625"/>
+            </a:xfrm>
+            <a:prstGeom prst="rect">
+              <a:avLst/>
+            </a:prstGeom>
+            <a:ln w="38100" cap="sq">
+              <a:solidFill>
+                <a:srgbClr val="000000"/>
+              </a:solidFill>
+              <a:prstDash val="solid"/>
+              <a:miter lim="800000"/>
+            </a:ln>
+            <a:effectLst>
+              <a:outerShdw blurRad="50800" dist="38100" dir="2700000" algn="tl" rotWithShape="0">
+                <a:srgbClr val="000000">
+                  <a:alpha val="43000"/>
+                </a:srgbClr>
+              </a:outerShdw>
+            </a:effectLst>
+          </p:spPr>
+        </p:pic>
+        <p:sp>
+          <p:nvSpPr>
+            <p:cNvPr id="9" name="Arrow: Down 8">
+              <a:extLst>
+                <a:ext uri="{FF2B5EF4-FFF2-40B4-BE49-F238E27FC236}">
+                  <a16:creationId xmlns:a16="http://schemas.microsoft.com/office/drawing/2014/main" id="{2C0CF051-A33F-5921-7263-60FD63FFF618}"/>
+                </a:ext>
+              </a:extLst>
+            </p:cNvPr>
+            <p:cNvSpPr/>
+            <p:nvPr/>
+          </p:nvSpPr>
+          <p:spPr>
+            <a:xfrm>
+              <a:off x="5492321" y="4185418"/>
+              <a:ext cx="386499" cy="358218"/>
+            </a:xfrm>
+            <a:prstGeom prst="downArrow">
+              <a:avLst/>
+            </a:prstGeom>
+          </p:spPr>
+          <p:style>
+            <a:lnRef idx="2">
+              <a:schemeClr val="dk1">
+                <a:shade val="15000"/>
+              </a:schemeClr>
+            </a:lnRef>
+            <a:fillRef idx="1">
+              <a:schemeClr val="dk1"/>
+            </a:fillRef>
+            <a:effectRef idx="0">
+              <a:schemeClr val="dk1"/>
+            </a:effectRef>
+            <a:fontRef idx="minor">
+              <a:schemeClr val="lt1"/>
+            </a:fontRef>
+          </p:style>
+          <p:txBody>
+            <a:bodyPr rtlCol="0" anchor="ctr"/>
+            <a:lstStyle/>
+            <a:p>
+              <a:pPr algn="ctr"/>
+              <a:endParaRPr lang="en-US"/>
+            </a:p>
+          </p:txBody>
+        </p:sp>
+      </p:grpSp>
+      <p:graphicFrame>
+        <p:nvGraphicFramePr>
+          <p:cNvPr id="11" name="Table 10">
+            <a:extLst>
+              <a:ext uri="{FF2B5EF4-FFF2-40B4-BE49-F238E27FC236}">
+                <a16:creationId xmlns:a16="http://schemas.microsoft.com/office/drawing/2014/main" id="{B2D51285-3DB7-14F1-27B9-EF23AFC885C1}"/>
+              </a:ext>
+            </a:extLst>
+          </p:cNvPr>
+          <p:cNvGraphicFramePr>
+            <a:graphicFrameLocks noGrp="1"/>
+          </p:cNvGraphicFramePr>
+          <p:nvPr>
+            <p:extLst>
+              <p:ext uri="{D42A27DB-BD31-4B8C-83A1-F6EECF244321}">
+                <p14:modId xmlns:p14="http://schemas.microsoft.com/office/powerpoint/2010/main" val="2147604987"/>
+              </p:ext>
+            </p:extLst>
+          </p:nvPr>
+        </p:nvGraphicFramePr>
+        <p:xfrm>
+          <a:off x="217714" y="1209539"/>
+          <a:ext cx="6965511" cy="1890580"/>
+        </p:xfrm>
+        <a:graphic>
+          <a:graphicData uri="http://schemas.openxmlformats.org/drawingml/2006/table">
+            <a:tbl>
+              <a:tblPr/>
+              <a:tblGrid>
+                <a:gridCol w="2995756">
+                  <a:extLst>
+                    <a:ext uri="{9D8B030D-6E8A-4147-A177-3AD203B41FA5}">
+                      <a16:colId xmlns:a16="http://schemas.microsoft.com/office/drawing/2014/main" val="933589240"/>
+                    </a:ext>
+                  </a:extLst>
+                </a:gridCol>
+                <a:gridCol w="3969755">
+                  <a:extLst>
+                    <a:ext uri="{9D8B030D-6E8A-4147-A177-3AD203B41FA5}">
+                      <a16:colId xmlns:a16="http://schemas.microsoft.com/office/drawing/2014/main" val="1541065414"/>
+                    </a:ext>
+                  </a:extLst>
+                </a:gridCol>
+              </a:tblGrid>
+              <a:tr h="378116">
+                <a:tc>
+                  <a:txBody>
+                    <a:bodyPr/>
+                    <a:lstStyle/>
+                    <a:p>
+                      <a:r>
+                        <a:rPr lang="en-US" sz="1400" b="1"/>
+                        <a:t>Metod</a:t>
+                      </a:r>
+                    </a:p>
+                  </a:txBody>
+                  <a:tcPr anchor="ctr">
+                    <a:lnL w="12700" cap="flat" cmpd="sng" algn="ctr">
+                      <a:solidFill>
+                        <a:schemeClr val="tx1"/>
+                      </a:solidFill>
+                      <a:prstDash val="solid"/>
+                      <a:round/>
+                      <a:headEnd type="none" w="med" len="med"/>
+                      <a:tailEnd type="none" w="med" len="med"/>
+                    </a:lnL>
+                    <a:lnR w="12700" cap="flat" cmpd="sng" algn="ctr">
+                      <a:solidFill>
+                        <a:schemeClr val="tx1"/>
+                      </a:solidFill>
+                      <a:prstDash val="solid"/>
+                      <a:round/>
+                      <a:headEnd type="none" w="med" len="med"/>
+                      <a:tailEnd type="none" w="med" len="med"/>
+                    </a:lnR>
+                    <a:lnT w="12700" cap="flat" cmpd="sng" algn="ctr">
+                      <a:solidFill>
+                        <a:schemeClr val="tx1"/>
+                      </a:solidFill>
+                      <a:prstDash val="solid"/>
+                      <a:round/>
+                      <a:headEnd type="none" w="med" len="med"/>
+                      <a:tailEnd type="none" w="med" len="med"/>
+                    </a:lnT>
+                    <a:lnB w="12700" cap="flat" cmpd="sng" algn="ctr">
+                      <a:solidFill>
+                        <a:schemeClr val="tx1"/>
+                      </a:solidFill>
+                      <a:prstDash val="solid"/>
+                      <a:round/>
+                      <a:headEnd type="none" w="med" len="med"/>
+                      <a:tailEnd type="none" w="med" len="med"/>
+                    </a:lnB>
+                    <a:solidFill>
+                      <a:schemeClr val="accent2"/>
+                    </a:solidFill>
+                  </a:tcPr>
+                </a:tc>
+                <a:tc>
+                  <a:txBody>
+                    <a:bodyPr/>
+                    <a:lstStyle/>
+                    <a:p>
+                      <a:r>
+                        <a:rPr lang="en-US" sz="1400" b="1"/>
+                        <a:t>Təyinat</a:t>
+                      </a:r>
+                    </a:p>
+                  </a:txBody>
+                  <a:tcPr anchor="ctr">
+                    <a:lnL w="12700" cap="flat" cmpd="sng" algn="ctr">
+                      <a:solidFill>
+                        <a:schemeClr val="tx1"/>
+                      </a:solidFill>
+                      <a:prstDash val="solid"/>
+                      <a:round/>
+                      <a:headEnd type="none" w="med" len="med"/>
+                      <a:tailEnd type="none" w="med" len="med"/>
+                    </a:lnL>
+                    <a:lnR w="12700" cap="flat" cmpd="sng" algn="ctr">
+                      <a:solidFill>
+                        <a:schemeClr val="tx1"/>
+                      </a:solidFill>
+                      <a:prstDash val="solid"/>
+                      <a:round/>
+                      <a:headEnd type="none" w="med" len="med"/>
+                      <a:tailEnd type="none" w="med" len="med"/>
+                    </a:lnR>
+                    <a:lnT w="12700" cap="flat" cmpd="sng" algn="ctr">
+                      <a:solidFill>
+                        <a:schemeClr val="tx1"/>
+                      </a:solidFill>
+                      <a:prstDash val="solid"/>
+                      <a:round/>
+                      <a:headEnd type="none" w="med" len="med"/>
+                      <a:tailEnd type="none" w="med" len="med"/>
+                    </a:lnT>
+                    <a:lnB w="12700" cap="flat" cmpd="sng" algn="ctr">
+                      <a:solidFill>
+                        <a:schemeClr val="tx1"/>
+                      </a:solidFill>
+                      <a:prstDash val="solid"/>
+                      <a:round/>
+                      <a:headEnd type="none" w="med" len="med"/>
+                      <a:tailEnd type="none" w="med" len="med"/>
+                    </a:lnB>
+                    <a:solidFill>
+                      <a:schemeClr val="accent2"/>
+                    </a:solidFill>
+                  </a:tcPr>
+                </a:tc>
+                <a:extLst>
+                  <a:ext uri="{0D108BD9-81ED-4DB2-BD59-A6C34878D82A}">
+                    <a16:rowId xmlns:a16="http://schemas.microsoft.com/office/drawing/2014/main" val="2690083897"/>
+                  </a:ext>
+                </a:extLst>
+              </a:tr>
+              <a:tr h="378116">
+                <a:tc>
+                  <a:txBody>
+                    <a:bodyPr/>
+                    <a:lstStyle/>
+                    <a:p>
+                      <a:r>
+                        <a:rPr lang="en-US" sz="1400"/>
+                        <a:t>$request-&gt;session()-&gt;forget('key')</a:t>
+                      </a:r>
+                    </a:p>
+                  </a:txBody>
+                  <a:tcPr anchor="ctr">
+                    <a:lnL w="12700" cap="flat" cmpd="sng" algn="ctr">
+                      <a:solidFill>
+                        <a:schemeClr val="tx1"/>
+                      </a:solidFill>
+                      <a:prstDash val="solid"/>
+                      <a:round/>
+                      <a:headEnd type="none" w="med" len="med"/>
+                      <a:tailEnd type="none" w="med" len="med"/>
+                    </a:lnL>
+                    <a:lnR w="12700" cap="flat" cmpd="sng" algn="ctr">
+                      <a:solidFill>
+                        <a:schemeClr val="tx1"/>
+                      </a:solidFill>
+                      <a:prstDash val="solid"/>
+                      <a:round/>
+                      <a:headEnd type="none" w="med" len="med"/>
+                      <a:tailEnd type="none" w="med" len="med"/>
+                    </a:lnR>
+                    <a:lnT w="12700" cap="flat" cmpd="sng" algn="ctr">
+                      <a:solidFill>
+                        <a:schemeClr val="tx1"/>
+                      </a:solidFill>
+                      <a:prstDash val="solid"/>
+                      <a:round/>
+                      <a:headEnd type="none" w="med" len="med"/>
+                      <a:tailEnd type="none" w="med" len="med"/>
+                    </a:lnT>
+                    <a:lnB w="12700" cap="flat" cmpd="sng" algn="ctr">
+                      <a:solidFill>
+                        <a:schemeClr val="tx1"/>
+                      </a:solidFill>
+                      <a:prstDash val="solid"/>
+                      <a:round/>
+                      <a:headEnd type="none" w="med" len="med"/>
+                      <a:tailEnd type="none" w="med" len="med"/>
+                    </a:lnB>
+                    <a:noFill/>
+                  </a:tcPr>
+                </a:tc>
+                <a:tc>
+                  <a:txBody>
+                    <a:bodyPr/>
+                    <a:lstStyle/>
+                    <a:p>
+                      <a:r>
+                        <a:rPr lang="en-US" sz="1400"/>
+                        <a:t>Tək bir məlumatı silir</a:t>
+                      </a:r>
+                    </a:p>
+                  </a:txBody>
+                  <a:tcPr anchor="ctr">
+                    <a:lnL w="12700" cap="flat" cmpd="sng" algn="ctr">
+                      <a:solidFill>
+                        <a:schemeClr val="tx1"/>
+                      </a:solidFill>
+                      <a:prstDash val="solid"/>
+                      <a:round/>
+                      <a:headEnd type="none" w="med" len="med"/>
+                      <a:tailEnd type="none" w="med" len="med"/>
+                    </a:lnL>
+                    <a:lnR w="12700" cap="flat" cmpd="sng" algn="ctr">
+                      <a:solidFill>
+                        <a:schemeClr val="tx1"/>
+                      </a:solidFill>
+                      <a:prstDash val="solid"/>
+                      <a:round/>
+                      <a:headEnd type="none" w="med" len="med"/>
+                      <a:tailEnd type="none" w="med" len="med"/>
+                    </a:lnR>
+                    <a:lnT w="12700" cap="flat" cmpd="sng" algn="ctr">
+                      <a:solidFill>
+                        <a:schemeClr val="tx1"/>
+                      </a:solidFill>
+                      <a:prstDash val="solid"/>
+                      <a:round/>
+                      <a:headEnd type="none" w="med" len="med"/>
+                      <a:tailEnd type="none" w="med" len="med"/>
+                    </a:lnT>
+                    <a:lnB w="12700" cap="flat" cmpd="sng" algn="ctr">
+                      <a:solidFill>
+                        <a:schemeClr val="tx1"/>
+                      </a:solidFill>
+                      <a:prstDash val="solid"/>
+                      <a:round/>
+                      <a:headEnd type="none" w="med" len="med"/>
+                      <a:tailEnd type="none" w="med" len="med"/>
+                    </a:lnB>
+                    <a:noFill/>
+                  </a:tcPr>
+                </a:tc>
+                <a:extLst>
+                  <a:ext uri="{0D108BD9-81ED-4DB2-BD59-A6C34878D82A}">
+                    <a16:rowId xmlns:a16="http://schemas.microsoft.com/office/drawing/2014/main" val="3759684584"/>
+                  </a:ext>
+                </a:extLst>
+              </a:tr>
+              <a:tr h="378116">
+                <a:tc>
+                  <a:txBody>
+                    <a:bodyPr/>
+                    <a:lstStyle/>
+                    <a:p>
+                      <a:r>
+                        <a:rPr lang="en-US" sz="1400"/>
+                        <a:t>$request-&gt;session()-&gt;forget([...])</a:t>
+                      </a:r>
+                    </a:p>
+                  </a:txBody>
+                  <a:tcPr anchor="ctr">
+                    <a:lnL w="12700" cap="flat" cmpd="sng" algn="ctr">
+                      <a:solidFill>
+                        <a:schemeClr val="tx1"/>
+                      </a:solidFill>
+                      <a:prstDash val="solid"/>
+                      <a:round/>
+                      <a:headEnd type="none" w="med" len="med"/>
+                      <a:tailEnd type="none" w="med" len="med"/>
+                    </a:lnL>
+                    <a:lnR w="12700" cap="flat" cmpd="sng" algn="ctr">
+                      <a:solidFill>
+                        <a:schemeClr val="tx1"/>
+                      </a:solidFill>
+                      <a:prstDash val="solid"/>
+                      <a:round/>
+                      <a:headEnd type="none" w="med" len="med"/>
+                      <a:tailEnd type="none" w="med" len="med"/>
+                    </a:lnR>
+                    <a:lnT w="12700" cap="flat" cmpd="sng" algn="ctr">
+                      <a:solidFill>
+                        <a:schemeClr val="tx1"/>
+                      </a:solidFill>
+                      <a:prstDash val="solid"/>
+                      <a:round/>
+                      <a:headEnd type="none" w="med" len="med"/>
+                      <a:tailEnd type="none" w="med" len="med"/>
+                    </a:lnT>
+                    <a:lnB w="12700" cap="flat" cmpd="sng" algn="ctr">
+                      <a:solidFill>
+                        <a:schemeClr val="tx1"/>
+                      </a:solidFill>
+                      <a:prstDash val="solid"/>
+                      <a:round/>
+                      <a:headEnd type="none" w="med" len="med"/>
+                      <a:tailEnd type="none" w="med" len="med"/>
+                    </a:lnB>
+                    <a:noFill/>
+                  </a:tcPr>
+                </a:tc>
+                <a:tc>
+                  <a:txBody>
+                    <a:bodyPr/>
+                    <a:lstStyle/>
+                    <a:p>
+                      <a:r>
+                        <a:rPr lang="en-US" sz="1400"/>
+                        <a:t>Birdən çox açarı silir</a:t>
+                      </a:r>
+                    </a:p>
+                  </a:txBody>
+                  <a:tcPr anchor="ctr">
+                    <a:lnL w="12700" cap="flat" cmpd="sng" algn="ctr">
+                      <a:solidFill>
+                        <a:schemeClr val="tx1"/>
+                      </a:solidFill>
+                      <a:prstDash val="solid"/>
+                      <a:round/>
+                      <a:headEnd type="none" w="med" len="med"/>
+                      <a:tailEnd type="none" w="med" len="med"/>
+                    </a:lnL>
+                    <a:lnR w="12700" cap="flat" cmpd="sng" algn="ctr">
+                      <a:solidFill>
+                        <a:schemeClr val="tx1"/>
+                      </a:solidFill>
+                      <a:prstDash val="solid"/>
+                      <a:round/>
+                      <a:headEnd type="none" w="med" len="med"/>
+                      <a:tailEnd type="none" w="med" len="med"/>
+                    </a:lnR>
+                    <a:lnT w="12700" cap="flat" cmpd="sng" algn="ctr">
+                      <a:solidFill>
+                        <a:schemeClr val="tx1"/>
+                      </a:solidFill>
+                      <a:prstDash val="solid"/>
+                      <a:round/>
+                      <a:headEnd type="none" w="med" len="med"/>
+                      <a:tailEnd type="none" w="med" len="med"/>
+                    </a:lnT>
+                    <a:lnB w="12700" cap="flat" cmpd="sng" algn="ctr">
+                      <a:solidFill>
+                        <a:schemeClr val="tx1"/>
+                      </a:solidFill>
+                      <a:prstDash val="solid"/>
+                      <a:round/>
+                      <a:headEnd type="none" w="med" len="med"/>
+                      <a:tailEnd type="none" w="med" len="med"/>
+                    </a:lnB>
+                    <a:noFill/>
+                  </a:tcPr>
+                </a:tc>
+                <a:extLst>
+                  <a:ext uri="{0D108BD9-81ED-4DB2-BD59-A6C34878D82A}">
+                    <a16:rowId xmlns:a16="http://schemas.microsoft.com/office/drawing/2014/main" val="1304971424"/>
+                  </a:ext>
+                </a:extLst>
+              </a:tr>
+              <a:tr h="378116">
+                <a:tc>
+                  <a:txBody>
+                    <a:bodyPr/>
+                    <a:lstStyle/>
+                    <a:p>
+                      <a:r>
+                        <a:rPr lang="en-US" sz="1400"/>
+                        <a:t>session()-&gt;flush()</a:t>
+                      </a:r>
+                    </a:p>
+                  </a:txBody>
+                  <a:tcPr anchor="ctr">
+                    <a:lnL w="12700" cap="flat" cmpd="sng" algn="ctr">
+                      <a:solidFill>
+                        <a:schemeClr val="tx1"/>
+                      </a:solidFill>
+                      <a:prstDash val="solid"/>
+                      <a:round/>
+                      <a:headEnd type="none" w="med" len="med"/>
+                      <a:tailEnd type="none" w="med" len="med"/>
+                    </a:lnL>
+                    <a:lnR w="12700" cap="flat" cmpd="sng" algn="ctr">
+                      <a:solidFill>
+                        <a:schemeClr val="tx1"/>
+                      </a:solidFill>
+                      <a:prstDash val="solid"/>
+                      <a:round/>
+                      <a:headEnd type="none" w="med" len="med"/>
+                      <a:tailEnd type="none" w="med" len="med"/>
+                    </a:lnR>
+                    <a:lnT w="12700" cap="flat" cmpd="sng" algn="ctr">
+                      <a:solidFill>
+                        <a:schemeClr val="tx1"/>
+                      </a:solidFill>
+                      <a:prstDash val="solid"/>
+                      <a:round/>
+                      <a:headEnd type="none" w="med" len="med"/>
+                      <a:tailEnd type="none" w="med" len="med"/>
+                    </a:lnT>
+                    <a:lnB w="12700" cap="flat" cmpd="sng" algn="ctr">
+                      <a:solidFill>
+                        <a:schemeClr val="tx1"/>
+                      </a:solidFill>
+                      <a:prstDash val="solid"/>
+                      <a:round/>
+                      <a:headEnd type="none" w="med" len="med"/>
+                      <a:tailEnd type="none" w="med" len="med"/>
+                    </a:lnB>
+                    <a:noFill/>
+                  </a:tcPr>
+                </a:tc>
+                <a:tc>
+                  <a:txBody>
+                    <a:bodyPr/>
+                    <a:lstStyle/>
+                    <a:p>
+                      <a:r>
+                        <a:rPr lang="en-US" sz="1400" b="1"/>
+                        <a:t>Bütün sessiya məlumatlarını silir</a:t>
+                      </a:r>
+                      <a:endParaRPr lang="en-US" sz="1400"/>
+                    </a:p>
+                  </a:txBody>
+                  <a:tcPr anchor="ctr">
+                    <a:lnL w="12700" cap="flat" cmpd="sng" algn="ctr">
+                      <a:solidFill>
+                        <a:schemeClr val="tx1"/>
+                      </a:solidFill>
+                      <a:prstDash val="solid"/>
+                      <a:round/>
+                      <a:headEnd type="none" w="med" len="med"/>
+                      <a:tailEnd type="none" w="med" len="med"/>
+                    </a:lnL>
+                    <a:lnR w="12700" cap="flat" cmpd="sng" algn="ctr">
+                      <a:solidFill>
+                        <a:schemeClr val="tx1"/>
+                      </a:solidFill>
+                      <a:prstDash val="solid"/>
+                      <a:round/>
+                      <a:headEnd type="none" w="med" len="med"/>
+                      <a:tailEnd type="none" w="med" len="med"/>
+                    </a:lnR>
+                    <a:lnT w="12700" cap="flat" cmpd="sng" algn="ctr">
+                      <a:solidFill>
+                        <a:schemeClr val="tx1"/>
+                      </a:solidFill>
+                      <a:prstDash val="solid"/>
+                      <a:round/>
+                      <a:headEnd type="none" w="med" len="med"/>
+                      <a:tailEnd type="none" w="med" len="med"/>
+                    </a:lnT>
+                    <a:lnB w="12700" cap="flat" cmpd="sng" algn="ctr">
+                      <a:solidFill>
+                        <a:schemeClr val="tx1"/>
+                      </a:solidFill>
+                      <a:prstDash val="solid"/>
+                      <a:round/>
+                      <a:headEnd type="none" w="med" len="med"/>
+                      <a:tailEnd type="none" w="med" len="med"/>
+                    </a:lnB>
+                    <a:noFill/>
+                  </a:tcPr>
+                </a:tc>
+                <a:extLst>
+                  <a:ext uri="{0D108BD9-81ED-4DB2-BD59-A6C34878D82A}">
+                    <a16:rowId xmlns:a16="http://schemas.microsoft.com/office/drawing/2014/main" val="1869547298"/>
+                  </a:ext>
+                </a:extLst>
+              </a:tr>
+              <a:tr h="378116">
+                <a:tc>
+                  <a:txBody>
+                    <a:bodyPr/>
+                    <a:lstStyle/>
+                    <a:p>
+                      <a:r>
+                        <a:rPr lang="en-US" sz="1400"/>
+                        <a:t>session()-&gt;invalidate()</a:t>
+                      </a:r>
+                    </a:p>
+                  </a:txBody>
+                  <a:tcPr anchor="ctr">
+                    <a:lnL w="12700" cap="flat" cmpd="sng" algn="ctr">
+                      <a:solidFill>
+                        <a:schemeClr val="tx1"/>
+                      </a:solidFill>
+                      <a:prstDash val="solid"/>
+                      <a:round/>
+                      <a:headEnd type="none" w="med" len="med"/>
+                      <a:tailEnd type="none" w="med" len="med"/>
+                    </a:lnL>
+                    <a:lnR w="12700" cap="flat" cmpd="sng" algn="ctr">
+                      <a:solidFill>
+                        <a:schemeClr val="tx1"/>
+                      </a:solidFill>
+                      <a:prstDash val="solid"/>
+                      <a:round/>
+                      <a:headEnd type="none" w="med" len="med"/>
+                      <a:tailEnd type="none" w="med" len="med"/>
+                    </a:lnR>
+                    <a:lnT w="12700" cap="flat" cmpd="sng" algn="ctr">
+                      <a:solidFill>
+                        <a:schemeClr val="tx1"/>
+                      </a:solidFill>
+                      <a:prstDash val="solid"/>
+                      <a:round/>
+                      <a:headEnd type="none" w="med" len="med"/>
+                      <a:tailEnd type="none" w="med" len="med"/>
+                    </a:lnT>
+                    <a:lnB w="12700" cap="flat" cmpd="sng" algn="ctr">
+                      <a:solidFill>
+                        <a:schemeClr val="tx1"/>
+                      </a:solidFill>
+                      <a:prstDash val="solid"/>
+                      <a:round/>
+                      <a:headEnd type="none" w="med" len="med"/>
+                      <a:tailEnd type="none" w="med" len="med"/>
+                    </a:lnB>
+                    <a:noFill/>
+                  </a:tcPr>
+                </a:tc>
+                <a:tc>
+                  <a:txBody>
+                    <a:bodyPr/>
+                    <a:lstStyle/>
+                    <a:p>
+                      <a:r>
+                        <a:rPr lang="en-US" sz="1400"/>
+                        <a:t>Sessiyanı tam </a:t>
+                      </a:r>
+                      <a:r>
+                        <a:rPr lang="en-US" sz="1400" b="1"/>
+                        <a:t>başdan sıfırlayır (ID-ni belə dəyişir)</a:t>
+                      </a:r>
+                      <a:endParaRPr lang="en-US" sz="1400"/>
+                    </a:p>
+                  </a:txBody>
+                  <a:tcPr anchor="ctr">
+                    <a:lnL w="12700" cap="flat" cmpd="sng" algn="ctr">
+                      <a:solidFill>
+                        <a:schemeClr val="tx1"/>
+                      </a:solidFill>
+                      <a:prstDash val="solid"/>
+                      <a:round/>
+                      <a:headEnd type="none" w="med" len="med"/>
+                      <a:tailEnd type="none" w="med" len="med"/>
+                    </a:lnL>
+                    <a:lnR w="12700" cap="flat" cmpd="sng" algn="ctr">
+                      <a:solidFill>
+                        <a:schemeClr val="tx1"/>
+                      </a:solidFill>
+                      <a:prstDash val="solid"/>
+                      <a:round/>
+                      <a:headEnd type="none" w="med" len="med"/>
+                      <a:tailEnd type="none" w="med" len="med"/>
+                    </a:lnR>
+                    <a:lnT w="12700" cap="flat" cmpd="sng" algn="ctr">
+                      <a:solidFill>
+                        <a:schemeClr val="tx1"/>
+                      </a:solidFill>
+                      <a:prstDash val="solid"/>
+                      <a:round/>
+                      <a:headEnd type="none" w="med" len="med"/>
+                      <a:tailEnd type="none" w="med" len="med"/>
+                    </a:lnT>
+                    <a:lnB w="12700" cap="flat" cmpd="sng" algn="ctr">
+                      <a:solidFill>
+                        <a:schemeClr val="tx1"/>
+                      </a:solidFill>
+                      <a:prstDash val="solid"/>
+                      <a:round/>
+                      <a:headEnd type="none" w="med" len="med"/>
+                      <a:tailEnd type="none" w="med" len="med"/>
+                    </a:lnB>
+                    <a:noFill/>
+                  </a:tcPr>
+                </a:tc>
+                <a:extLst>
+                  <a:ext uri="{0D108BD9-81ED-4DB2-BD59-A6C34878D82A}">
+                    <a16:rowId xmlns:a16="http://schemas.microsoft.com/office/drawing/2014/main" val="555731049"/>
+                  </a:ext>
+                </a:extLst>
+              </a:tr>
+            </a:tbl>
+          </a:graphicData>
+        </a:graphic>
+      </p:graphicFrame>
     </p:spTree>
     <p:extLst>
       <p:ext uri="{BB962C8B-B14F-4D97-AF65-F5344CB8AC3E}">
@@ -3435,7 +4705,7 @@
         <p:spPr>
           <a:xfrm>
             <a:off x="217714" y="255046"/>
-            <a:ext cx="11756571" cy="355354"/>
+            <a:ext cx="11756571" cy="2455929"/>
           </a:xfrm>
           <a:prstGeom prst="rect">
             <a:avLst/>
@@ -3448,11 +4718,12 @@
           </a:bodyPr>
           <a:lstStyle/>
           <a:p>
-            <a:pPr>
+            <a:pPr marL="285750" indent="-285750">
               <a:lnSpc>
                 <a:spcPct val="150000"/>
               </a:lnSpc>
-              <a:buNone/>
+              <a:buFont typeface="Arial" panose="020B0604020202020204" pitchFamily="34" charset="0"/>
+              <a:buChar char="•"/>
             </a:pPr>
             <a:r>
               <a:rPr kumimoji="0" lang="en-US" altLang="en-US" sz="1300" b="0" i="0" u="none" strike="noStrike" cap="none" normalizeH="0" baseline="0">
@@ -3465,11 +4736,320 @@
                 <a:effectLst/>
                 <a:latin typeface="Arial" panose="020B0604020202020204" pitchFamily="34" charset="0"/>
               </a:rPr>
-              <a:t>.</a:t>
-            </a:r>
+              <a:t>Burada bir neçə sessiya açarı bir anda silinir.</a:t>
+            </a:r>
+          </a:p>
+          <a:p>
+            <a:pPr marL="285750" indent="-285750">
+              <a:lnSpc>
+                <a:spcPct val="150000"/>
+              </a:lnSpc>
+              <a:buFont typeface="Arial" panose="020B0604020202020204" pitchFamily="34" charset="0"/>
+              <a:buChar char="•"/>
+            </a:pPr>
+            <a:endParaRPr kumimoji="0" lang="en-US" altLang="en-US" sz="1300" b="0" i="0" u="none" strike="noStrike" cap="none" normalizeH="0" baseline="0">
+              <a:ln>
+                <a:noFill/>
+              </a:ln>
+              <a:solidFill>
+                <a:schemeClr val="tx1"/>
+              </a:solidFill>
+              <a:effectLst/>
+              <a:latin typeface="Arial" panose="020B0604020202020204" pitchFamily="34" charset="0"/>
+            </a:endParaRPr>
+          </a:p>
+          <a:p>
+            <a:pPr marL="285750" indent="-285750">
+              <a:lnSpc>
+                <a:spcPct val="150000"/>
+              </a:lnSpc>
+              <a:buFont typeface="Arial" panose="020B0604020202020204" pitchFamily="34" charset="0"/>
+              <a:buChar char="•"/>
+            </a:pPr>
+            <a:r>
+              <a:rPr kumimoji="0" lang="en-US" altLang="en-US" sz="1300" b="1" i="0" u="none" strike="noStrike" cap="none" normalizeH="0" baseline="0">
+                <a:ln>
+                  <a:noFill/>
+                </a:ln>
+                <a:solidFill>
+                  <a:schemeClr val="tx1"/>
+                </a:solidFill>
+                <a:effectLst/>
+                <a:latin typeface="Arial" panose="020B0604020202020204" pitchFamily="34" charset="0"/>
+              </a:rPr>
+              <a:t>forget([...]) </a:t>
+            </a:r>
+            <a:r>
+              <a:rPr kumimoji="0" lang="en-US" altLang="en-US" sz="1300" b="0" i="0" u="none" strike="noStrike" cap="none" normalizeH="0" baseline="0">
+                <a:ln>
+                  <a:noFill/>
+                </a:ln>
+                <a:solidFill>
+                  <a:schemeClr val="tx1"/>
+                </a:solidFill>
+                <a:effectLst/>
+                <a:latin typeface="Arial" panose="020B0604020202020204" pitchFamily="34" charset="0"/>
+              </a:rPr>
+              <a:t>massiv şəklində birdən çox açarı qəbul edir.</a:t>
+            </a:r>
+          </a:p>
+          <a:p>
+            <a:pPr marL="285750" indent="-285750">
+              <a:lnSpc>
+                <a:spcPct val="150000"/>
+              </a:lnSpc>
+              <a:buFont typeface="Arial" panose="020B0604020202020204" pitchFamily="34" charset="0"/>
+              <a:buChar char="•"/>
+            </a:pPr>
+            <a:endParaRPr kumimoji="0" lang="en-US" altLang="en-US" sz="1300" b="0" i="0" u="none" strike="noStrike" cap="none" normalizeH="0" baseline="0">
+              <a:ln>
+                <a:noFill/>
+              </a:ln>
+              <a:solidFill>
+                <a:schemeClr val="tx1"/>
+              </a:solidFill>
+              <a:effectLst/>
+              <a:latin typeface="Arial" panose="020B0604020202020204" pitchFamily="34" charset="0"/>
+            </a:endParaRPr>
+          </a:p>
+          <a:p>
+            <a:pPr marL="285750" indent="-285750">
+              <a:lnSpc>
+                <a:spcPct val="150000"/>
+              </a:lnSpc>
+              <a:buFont typeface="Arial" panose="020B0604020202020204" pitchFamily="34" charset="0"/>
+              <a:buChar char="•"/>
+            </a:pPr>
+            <a:r>
+              <a:rPr kumimoji="0" lang="en-US" altLang="en-US" sz="1300" b="0" i="0" u="none" strike="noStrike" cap="none" normalizeH="0" baseline="0">
+                <a:ln>
+                  <a:noFill/>
+                </a:ln>
+                <a:solidFill>
+                  <a:schemeClr val="tx1"/>
+                </a:solidFill>
+                <a:effectLst/>
+                <a:latin typeface="Arial" panose="020B0604020202020204" pitchFamily="34" charset="0"/>
+              </a:rPr>
+              <a:t>Qalan sessiya məlumatları toxunulmaz qalır.</a:t>
+            </a:r>
+            <a:endParaRPr kumimoji="0" lang="az-Latn-AZ" altLang="en-US" sz="1300" b="0" i="0" u="none" strike="noStrike" cap="none" normalizeH="0" baseline="0">
+              <a:ln>
+                <a:noFill/>
+              </a:ln>
+              <a:solidFill>
+                <a:schemeClr val="tx1"/>
+              </a:solidFill>
+              <a:effectLst/>
+              <a:latin typeface="Arial" panose="020B0604020202020204" pitchFamily="34" charset="0"/>
+            </a:endParaRPr>
+          </a:p>
+          <a:p>
+            <a:pPr>
+              <a:lnSpc>
+                <a:spcPct val="150000"/>
+              </a:lnSpc>
+              <a:buNone/>
+            </a:pPr>
+            <a:endParaRPr lang="az-Latn-AZ" altLang="en-US" sz="1300">
+              <a:latin typeface="Arial" panose="020B0604020202020204" pitchFamily="34" charset="0"/>
+            </a:endParaRPr>
+          </a:p>
+          <a:p>
+            <a:pPr>
+              <a:lnSpc>
+                <a:spcPct val="150000"/>
+              </a:lnSpc>
+              <a:buNone/>
+            </a:pPr>
+            <a:endParaRPr kumimoji="0" lang="az-Latn-AZ" altLang="en-US" sz="1300" b="0" i="0" u="none" strike="noStrike" cap="none" normalizeH="0" baseline="0">
+              <a:ln>
+                <a:noFill/>
+              </a:ln>
+              <a:solidFill>
+                <a:schemeClr val="tx1"/>
+              </a:solidFill>
+              <a:effectLst/>
+              <a:latin typeface="Arial" panose="020B0604020202020204" pitchFamily="34" charset="0"/>
+            </a:endParaRPr>
+          </a:p>
+          <a:p>
+            <a:pPr>
+              <a:lnSpc>
+                <a:spcPct val="150000"/>
+              </a:lnSpc>
+              <a:buNone/>
+            </a:pPr>
+            <a:endParaRPr kumimoji="0" lang="en-US" altLang="en-US" sz="1300" b="0" i="0" u="none" strike="noStrike" cap="none" normalizeH="0" baseline="0">
+              <a:ln>
+                <a:noFill/>
+              </a:ln>
+              <a:solidFill>
+                <a:schemeClr val="tx1"/>
+              </a:solidFill>
+              <a:effectLst/>
+              <a:latin typeface="Arial" panose="020B0604020202020204" pitchFamily="34" charset="0"/>
+            </a:endParaRPr>
           </a:p>
         </p:txBody>
       </p:sp>
+      <p:pic>
+        <p:nvPicPr>
+          <p:cNvPr id="4" name="Picture 3">
+            <a:extLst>
+              <a:ext uri="{FF2B5EF4-FFF2-40B4-BE49-F238E27FC236}">
+                <a16:creationId xmlns:a16="http://schemas.microsoft.com/office/drawing/2014/main" id="{82B97806-3AB2-62EC-AA0A-8C0D43DC476E}"/>
+              </a:ext>
+            </a:extLst>
+          </p:cNvPr>
+          <p:cNvPicPr>
+            <a:picLocks noChangeAspect="1"/>
+          </p:cNvPicPr>
+          <p:nvPr/>
+        </p:nvPicPr>
+        <p:blipFill>
+          <a:blip r:embed="rId2"/>
+          <a:stretch>
+            <a:fillRect/>
+          </a:stretch>
+        </p:blipFill>
+        <p:spPr>
+          <a:xfrm>
+            <a:off x="7797476" y="0"/>
+            <a:ext cx="4394524" cy="6858000"/>
+          </a:xfrm>
+          <a:prstGeom prst="rect">
+            <a:avLst/>
+          </a:prstGeom>
+        </p:spPr>
+      </p:pic>
+      <p:grpSp>
+        <p:nvGrpSpPr>
+          <p:cNvPr id="10" name="Group 9">
+            <a:extLst>
+              <a:ext uri="{FF2B5EF4-FFF2-40B4-BE49-F238E27FC236}">
+                <a16:creationId xmlns:a16="http://schemas.microsoft.com/office/drawing/2014/main" id="{60F07B0F-A54A-919F-4DD0-95DE9EB65C40}"/>
+              </a:ext>
+            </a:extLst>
+          </p:cNvPr>
+          <p:cNvGrpSpPr/>
+          <p:nvPr/>
+        </p:nvGrpSpPr>
+        <p:grpSpPr>
+          <a:xfrm>
+            <a:off x="3534824" y="3880911"/>
+            <a:ext cx="3958789" cy="2977089"/>
+            <a:chOff x="3449983" y="3473777"/>
+            <a:chExt cx="3958789" cy="2977089"/>
+          </a:xfrm>
+        </p:grpSpPr>
+        <p:pic>
+          <p:nvPicPr>
+            <p:cNvPr id="6" name="Picture 5">
+              <a:extLst>
+                <a:ext uri="{FF2B5EF4-FFF2-40B4-BE49-F238E27FC236}">
+                  <a16:creationId xmlns:a16="http://schemas.microsoft.com/office/drawing/2014/main" id="{A149916C-1DDC-DD98-E80C-874D1F479C82}"/>
+                </a:ext>
+              </a:extLst>
+            </p:cNvPr>
+            <p:cNvPicPr>
+              <a:picLocks noChangeAspect="1"/>
+            </p:cNvPicPr>
+            <p:nvPr/>
+          </p:nvPicPr>
+          <p:blipFill>
+            <a:blip r:embed="rId3"/>
+            <a:stretch>
+              <a:fillRect/>
+            </a:stretch>
+          </p:blipFill>
+          <p:spPr>
+            <a:xfrm>
+              <a:off x="3449983" y="3473777"/>
+              <a:ext cx="3953427" cy="733527"/>
+            </a:xfrm>
+            <a:prstGeom prst="rect">
+              <a:avLst/>
+            </a:prstGeom>
+          </p:spPr>
+        </p:pic>
+        <p:pic>
+          <p:nvPicPr>
+            <p:cNvPr id="8" name="Picture 7">
+              <a:extLst>
+                <a:ext uri="{FF2B5EF4-FFF2-40B4-BE49-F238E27FC236}">
+                  <a16:creationId xmlns:a16="http://schemas.microsoft.com/office/drawing/2014/main" id="{E5E7ECBD-117B-5849-60E1-28D123938886}"/>
+                </a:ext>
+              </a:extLst>
+            </p:cNvPr>
+            <p:cNvPicPr>
+              <a:picLocks noChangeAspect="1"/>
+            </p:cNvPicPr>
+            <p:nvPr/>
+          </p:nvPicPr>
+          <p:blipFill>
+            <a:blip r:embed="rId4"/>
+            <a:stretch>
+              <a:fillRect/>
+            </a:stretch>
+          </p:blipFill>
+          <p:spPr>
+            <a:xfrm>
+              <a:off x="3449983" y="4732256"/>
+              <a:ext cx="3958789" cy="1718610"/>
+            </a:xfrm>
+            <a:prstGeom prst="rect">
+              <a:avLst/>
+            </a:prstGeom>
+          </p:spPr>
+        </p:pic>
+        <p:sp>
+          <p:nvSpPr>
+            <p:cNvPr id="9" name="Arrow: Down 8">
+              <a:extLst>
+                <a:ext uri="{FF2B5EF4-FFF2-40B4-BE49-F238E27FC236}">
+                  <a16:creationId xmlns:a16="http://schemas.microsoft.com/office/drawing/2014/main" id="{97253EEB-1F74-793D-B6D2-FBFA157788A8}"/>
+                </a:ext>
+              </a:extLst>
+            </p:cNvPr>
+            <p:cNvSpPr/>
+            <p:nvPr/>
+          </p:nvSpPr>
+          <p:spPr>
+            <a:xfrm>
+              <a:off x="5309495" y="4267104"/>
+              <a:ext cx="414779" cy="405352"/>
+            </a:xfrm>
+            <a:prstGeom prst="downArrow">
+              <a:avLst/>
+            </a:prstGeom>
+          </p:spPr>
+          <p:style>
+            <a:lnRef idx="2">
+              <a:schemeClr val="dk1">
+                <a:shade val="15000"/>
+              </a:schemeClr>
+            </a:lnRef>
+            <a:fillRef idx="1">
+              <a:schemeClr val="dk1"/>
+            </a:fillRef>
+            <a:effectRef idx="0">
+              <a:schemeClr val="dk1"/>
+            </a:effectRef>
+            <a:fontRef idx="minor">
+              <a:schemeClr val="lt1"/>
+            </a:fontRef>
+          </p:style>
+          <p:txBody>
+            <a:bodyPr rtlCol="0" anchor="ctr"/>
+            <a:lstStyle/>
+            <a:p>
+              <a:pPr algn="ctr"/>
+              <a:endParaRPr lang="en-US"/>
+            </a:p>
+          </p:txBody>
+        </p:sp>
+      </p:grpSp>
     </p:spTree>
     <p:extLst>
       <p:ext uri="{BB962C8B-B14F-4D97-AF65-F5344CB8AC3E}">
@@ -3521,6 +5101,1855 @@
         <p:spPr>
           <a:xfrm>
             <a:off x="217714" y="255046"/>
+            <a:ext cx="11756571" cy="2756011"/>
+          </a:xfrm>
+          <a:prstGeom prst="rect">
+            <a:avLst/>
+          </a:prstGeom>
+          <a:noFill/>
+        </p:spPr>
+        <p:txBody>
+          <a:bodyPr wrap="square">
+            <a:spAutoFit/>
+          </a:bodyPr>
+          <a:lstStyle/>
+          <a:p>
+            <a:pPr marL="285750" indent="-285750">
+              <a:lnSpc>
+                <a:spcPct val="150000"/>
+              </a:lnSpc>
+              <a:buFont typeface="Arial" panose="020B0604020202020204" pitchFamily="34" charset="0"/>
+              <a:buChar char="•"/>
+            </a:pPr>
+            <a:r>
+              <a:rPr kumimoji="0" lang="en-US" altLang="en-US" sz="1300" b="1" i="0" u="none" strike="noStrike" cap="none" normalizeH="0" baseline="0">
+                <a:ln>
+                  <a:noFill/>
+                </a:ln>
+                <a:solidFill>
+                  <a:schemeClr val="tx1"/>
+                </a:solidFill>
+                <a:effectLst/>
+                <a:latin typeface="Arial" panose="020B0604020202020204" pitchFamily="34" charset="0"/>
+              </a:rPr>
+              <a:t>flush() </a:t>
+            </a:r>
+            <a:r>
+              <a:rPr kumimoji="0" lang="en-US" altLang="en-US" sz="1300" b="0" i="0" u="none" strike="noStrike" cap="none" normalizeH="0" baseline="0">
+                <a:ln>
+                  <a:noFill/>
+                </a:ln>
+                <a:solidFill>
+                  <a:schemeClr val="tx1"/>
+                </a:solidFill>
+                <a:effectLst/>
+                <a:latin typeface="Arial" panose="020B0604020202020204" pitchFamily="34" charset="0"/>
+              </a:rPr>
+              <a:t>metodu sessiyadakı bütün məlumatları silir.</a:t>
+            </a:r>
+          </a:p>
+          <a:p>
+            <a:pPr marL="285750" indent="-285750">
+              <a:lnSpc>
+                <a:spcPct val="150000"/>
+              </a:lnSpc>
+              <a:buFont typeface="Arial" panose="020B0604020202020204" pitchFamily="34" charset="0"/>
+              <a:buChar char="•"/>
+            </a:pPr>
+            <a:endParaRPr kumimoji="0" lang="en-US" altLang="en-US" sz="1300" b="0" i="0" u="none" strike="noStrike" cap="none" normalizeH="0" baseline="0">
+              <a:ln>
+                <a:noFill/>
+              </a:ln>
+              <a:solidFill>
+                <a:schemeClr val="tx1"/>
+              </a:solidFill>
+              <a:effectLst/>
+              <a:latin typeface="Arial" panose="020B0604020202020204" pitchFamily="34" charset="0"/>
+            </a:endParaRPr>
+          </a:p>
+          <a:p>
+            <a:pPr marL="285750" indent="-285750">
+              <a:lnSpc>
+                <a:spcPct val="150000"/>
+              </a:lnSpc>
+              <a:buFont typeface="Arial" panose="020B0604020202020204" pitchFamily="34" charset="0"/>
+              <a:buChar char="•"/>
+            </a:pPr>
+            <a:r>
+              <a:rPr kumimoji="0" lang="en-US" altLang="en-US" sz="1300" b="0" i="0" u="none" strike="noStrike" cap="none" normalizeH="0" baseline="0">
+                <a:ln>
+                  <a:noFill/>
+                </a:ln>
+                <a:solidFill>
+                  <a:schemeClr val="tx1"/>
+                </a:solidFill>
+                <a:effectLst/>
+                <a:latin typeface="Arial" panose="020B0604020202020204" pitchFamily="34" charset="0"/>
+              </a:rPr>
+              <a:t>Yəni artıq </a:t>
+            </a:r>
+            <a:r>
+              <a:rPr kumimoji="0" lang="en-US" altLang="en-US" sz="1300" b="1" i="0" u="none" strike="noStrike" cap="none" normalizeH="0" baseline="0">
+                <a:ln>
+                  <a:noFill/>
+                </a:ln>
+                <a:solidFill>
+                  <a:schemeClr val="tx1"/>
+                </a:solidFill>
+                <a:effectLst/>
+                <a:latin typeface="Arial" panose="020B0604020202020204" pitchFamily="34" charset="0"/>
+              </a:rPr>
+              <a:t>session()-&gt;all()</a:t>
+            </a:r>
+            <a:r>
+              <a:rPr kumimoji="0" lang="en-US" altLang="en-US" sz="1300" b="0" i="0" u="none" strike="noStrike" cap="none" normalizeH="0" baseline="0">
+                <a:ln>
+                  <a:noFill/>
+                </a:ln>
+                <a:solidFill>
+                  <a:schemeClr val="tx1"/>
+                </a:solidFill>
+                <a:effectLst/>
+                <a:latin typeface="Arial" panose="020B0604020202020204" pitchFamily="34" charset="0"/>
+              </a:rPr>
+              <a:t> içərisində heç nə qalmayacaq.</a:t>
+            </a:r>
+          </a:p>
+          <a:p>
+            <a:pPr marL="285750" indent="-285750">
+              <a:lnSpc>
+                <a:spcPct val="150000"/>
+              </a:lnSpc>
+              <a:buFont typeface="Arial" panose="020B0604020202020204" pitchFamily="34" charset="0"/>
+              <a:buChar char="•"/>
+            </a:pPr>
+            <a:endParaRPr kumimoji="0" lang="en-US" altLang="en-US" sz="1300" b="0" i="0" u="none" strike="noStrike" cap="none" normalizeH="0" baseline="0">
+              <a:ln>
+                <a:noFill/>
+              </a:ln>
+              <a:solidFill>
+                <a:schemeClr val="tx1"/>
+              </a:solidFill>
+              <a:effectLst/>
+              <a:latin typeface="Arial" panose="020B0604020202020204" pitchFamily="34" charset="0"/>
+            </a:endParaRPr>
+          </a:p>
+          <a:p>
+            <a:pPr marL="285750" indent="-285750">
+              <a:lnSpc>
+                <a:spcPct val="150000"/>
+              </a:lnSpc>
+              <a:buFont typeface="Arial" panose="020B0604020202020204" pitchFamily="34" charset="0"/>
+              <a:buChar char="•"/>
+            </a:pPr>
+            <a:r>
+              <a:rPr kumimoji="0" lang="en-US" altLang="en-US" sz="1300" b="0" i="0" u="none" strike="noStrike" cap="none" normalizeH="0" baseline="0">
+                <a:ln>
+                  <a:noFill/>
+                </a:ln>
+                <a:solidFill>
+                  <a:schemeClr val="tx1"/>
+                </a:solidFill>
+                <a:effectLst/>
+                <a:latin typeface="Arial" panose="020B0604020202020204" pitchFamily="34" charset="0"/>
+              </a:rPr>
+              <a:t>Bu</a:t>
+            </a:r>
+            <a:r>
+              <a:rPr kumimoji="0" lang="az-Latn-AZ" altLang="en-US" sz="1300" b="0" i="0" u="none" strike="noStrike" cap="none" normalizeH="0" baseline="0">
+                <a:ln>
+                  <a:noFill/>
+                </a:ln>
+                <a:solidFill>
+                  <a:schemeClr val="tx1"/>
+                </a:solidFill>
+                <a:effectLst/>
+                <a:latin typeface="Arial" panose="020B0604020202020204" pitchFamily="34" charset="0"/>
+              </a:rPr>
+              <a:t> metod, çox vaxt</a:t>
+            </a:r>
+            <a:r>
+              <a:rPr kumimoji="0" lang="en-US" altLang="en-US" sz="1300" b="0" i="0" u="none" strike="noStrike" cap="none" normalizeH="0" baseline="0">
+                <a:ln>
+                  <a:noFill/>
+                </a:ln>
+                <a:solidFill>
+                  <a:schemeClr val="tx1"/>
+                </a:solidFill>
+                <a:effectLst/>
+                <a:latin typeface="Arial" panose="020B0604020202020204" pitchFamily="34" charset="0"/>
+              </a:rPr>
+              <a:t> istifadəçi çıxış edəndə (logout) istifadə olunur.</a:t>
+            </a:r>
+            <a:endParaRPr kumimoji="0" lang="az-Latn-AZ" altLang="en-US" sz="1300" b="0" i="0" u="none" strike="noStrike" cap="none" normalizeH="0" baseline="0">
+              <a:ln>
+                <a:noFill/>
+              </a:ln>
+              <a:solidFill>
+                <a:schemeClr val="tx1"/>
+              </a:solidFill>
+              <a:effectLst/>
+              <a:latin typeface="Arial" panose="020B0604020202020204" pitchFamily="34" charset="0"/>
+            </a:endParaRPr>
+          </a:p>
+          <a:p>
+            <a:pPr>
+              <a:lnSpc>
+                <a:spcPct val="150000"/>
+              </a:lnSpc>
+              <a:buNone/>
+            </a:pPr>
+            <a:endParaRPr lang="az-Latn-AZ" altLang="en-US" sz="1300">
+              <a:latin typeface="Arial" panose="020B0604020202020204" pitchFamily="34" charset="0"/>
+            </a:endParaRPr>
+          </a:p>
+          <a:p>
+            <a:pPr>
+              <a:lnSpc>
+                <a:spcPct val="150000"/>
+              </a:lnSpc>
+              <a:buNone/>
+            </a:pPr>
+            <a:endParaRPr kumimoji="0" lang="az-Latn-AZ" altLang="en-US" sz="1300" b="0" i="0" u="none" strike="noStrike" cap="none" normalizeH="0" baseline="0">
+              <a:ln>
+                <a:noFill/>
+              </a:ln>
+              <a:solidFill>
+                <a:schemeClr val="tx1"/>
+              </a:solidFill>
+              <a:effectLst/>
+              <a:latin typeface="Arial" panose="020B0604020202020204" pitchFamily="34" charset="0"/>
+            </a:endParaRPr>
+          </a:p>
+          <a:p>
+            <a:pPr>
+              <a:lnSpc>
+                <a:spcPct val="150000"/>
+              </a:lnSpc>
+              <a:buNone/>
+            </a:pPr>
+            <a:endParaRPr kumimoji="0" lang="az-Latn-AZ" altLang="en-US" sz="1300" b="0" i="0" u="none" strike="noStrike" cap="none" normalizeH="0" baseline="0">
+              <a:ln>
+                <a:noFill/>
+              </a:ln>
+              <a:solidFill>
+                <a:schemeClr val="tx1"/>
+              </a:solidFill>
+              <a:effectLst/>
+              <a:latin typeface="Arial" panose="020B0604020202020204" pitchFamily="34" charset="0"/>
+            </a:endParaRPr>
+          </a:p>
+          <a:p>
+            <a:pPr>
+              <a:lnSpc>
+                <a:spcPct val="150000"/>
+              </a:lnSpc>
+              <a:buNone/>
+            </a:pPr>
+            <a:r>
+              <a:rPr lang="az-Latn-AZ" altLang="en-US" sz="1300" b="1">
+                <a:solidFill>
+                  <a:schemeClr val="accent2"/>
+                </a:solidFill>
+                <a:latin typeface="Arial" panose="020B0604020202020204" pitchFamily="34" charset="0"/>
+              </a:rPr>
+              <a:t>NOT</a:t>
+            </a:r>
+            <a:r>
+              <a:rPr lang="az-Latn-AZ" altLang="en-US" sz="1300">
+                <a:latin typeface="Arial" panose="020B0604020202020204" pitchFamily="34" charset="0"/>
+              </a:rPr>
+              <a:t>: </a:t>
+            </a:r>
+            <a:r>
+              <a:rPr lang="az-Latn-AZ" altLang="en-US" sz="1300" b="1">
+                <a:solidFill>
+                  <a:srgbClr val="00B050"/>
+                </a:solidFill>
+                <a:latin typeface="Arial" panose="020B0604020202020204" pitchFamily="34" charset="0"/>
+              </a:rPr>
+              <a:t>FLUSH</a:t>
+            </a:r>
+            <a:r>
+              <a:rPr lang="az-Latn-AZ" altLang="en-US" sz="1300">
+                <a:latin typeface="Arial" panose="020B0604020202020204" pitchFamily="34" charset="0"/>
+              </a:rPr>
+              <a:t> ilə </a:t>
+            </a:r>
+            <a:r>
+              <a:rPr lang="az-Latn-AZ" altLang="en-US" sz="1300" b="1">
+                <a:solidFill>
+                  <a:srgbClr val="0070C0"/>
+                </a:solidFill>
+                <a:latin typeface="Arial" panose="020B0604020202020204" pitchFamily="34" charset="0"/>
+              </a:rPr>
+              <a:t>FLASH</a:t>
+            </a:r>
+            <a:r>
+              <a:rPr lang="az-Latn-AZ" altLang="en-US" sz="1300">
+                <a:latin typeface="Arial" panose="020B0604020202020204" pitchFamily="34" charset="0"/>
+              </a:rPr>
+              <a:t> -I səhf salmayarsız....!!! Növbəti dərs. </a:t>
+            </a:r>
+            <a:endParaRPr kumimoji="0" lang="en-US" altLang="en-US" sz="1300" b="0" i="0" u="none" strike="noStrike" cap="none" normalizeH="0" baseline="0">
+              <a:ln>
+                <a:noFill/>
+              </a:ln>
+              <a:solidFill>
+                <a:schemeClr val="tx1"/>
+              </a:solidFill>
+              <a:effectLst/>
+              <a:latin typeface="Arial" panose="020B0604020202020204" pitchFamily="34" charset="0"/>
+            </a:endParaRPr>
+          </a:p>
+        </p:txBody>
+      </p:sp>
+      <p:pic>
+        <p:nvPicPr>
+          <p:cNvPr id="4" name="Picture 3">
+            <a:extLst>
+              <a:ext uri="{FF2B5EF4-FFF2-40B4-BE49-F238E27FC236}">
+                <a16:creationId xmlns:a16="http://schemas.microsoft.com/office/drawing/2014/main" id="{9A87C0BA-3480-6DFF-5D15-E8E9296C9042}"/>
+              </a:ext>
+            </a:extLst>
+          </p:cNvPr>
+          <p:cNvPicPr>
+            <a:picLocks noChangeAspect="1"/>
+          </p:cNvPicPr>
+          <p:nvPr/>
+        </p:nvPicPr>
+        <p:blipFill>
+          <a:blip r:embed="rId2"/>
+          <a:stretch>
+            <a:fillRect/>
+          </a:stretch>
+        </p:blipFill>
+        <p:spPr>
+          <a:xfrm>
+            <a:off x="7362533" y="0"/>
+            <a:ext cx="4829467" cy="6858000"/>
+          </a:xfrm>
+          <a:prstGeom prst="rect">
+            <a:avLst/>
+          </a:prstGeom>
+        </p:spPr>
+      </p:pic>
+      <p:grpSp>
+        <p:nvGrpSpPr>
+          <p:cNvPr id="10" name="Group 9">
+            <a:extLst>
+              <a:ext uri="{FF2B5EF4-FFF2-40B4-BE49-F238E27FC236}">
+                <a16:creationId xmlns:a16="http://schemas.microsoft.com/office/drawing/2014/main" id="{8E9BCC7A-F623-C38C-3610-BA7DA1953366}"/>
+              </a:ext>
+            </a:extLst>
+          </p:cNvPr>
+          <p:cNvGrpSpPr/>
+          <p:nvPr/>
+        </p:nvGrpSpPr>
+        <p:grpSpPr>
+          <a:xfrm>
+            <a:off x="2926845" y="3202756"/>
+            <a:ext cx="3943900" cy="3646195"/>
+            <a:chOff x="2926845" y="3202756"/>
+            <a:chExt cx="3943900" cy="3646195"/>
+          </a:xfrm>
+        </p:grpSpPr>
+        <p:pic>
+          <p:nvPicPr>
+            <p:cNvPr id="6" name="Picture 5">
+              <a:extLst>
+                <a:ext uri="{FF2B5EF4-FFF2-40B4-BE49-F238E27FC236}">
+                  <a16:creationId xmlns:a16="http://schemas.microsoft.com/office/drawing/2014/main" id="{46A565D1-EB64-0658-3A3B-E52C0445AD56}"/>
+                </a:ext>
+              </a:extLst>
+            </p:cNvPr>
+            <p:cNvPicPr>
+              <a:picLocks noChangeAspect="1"/>
+            </p:cNvPicPr>
+            <p:nvPr/>
+          </p:nvPicPr>
+          <p:blipFill>
+            <a:blip r:embed="rId3"/>
+            <a:stretch>
+              <a:fillRect/>
+            </a:stretch>
+          </p:blipFill>
+          <p:spPr>
+            <a:xfrm>
+              <a:off x="2926845" y="3202756"/>
+              <a:ext cx="3943900" cy="762106"/>
+            </a:xfrm>
+            <a:prstGeom prst="rect">
+              <a:avLst/>
+            </a:prstGeom>
+          </p:spPr>
+        </p:pic>
+        <p:pic>
+          <p:nvPicPr>
+            <p:cNvPr id="8" name="Picture 7">
+              <a:extLst>
+                <a:ext uri="{FF2B5EF4-FFF2-40B4-BE49-F238E27FC236}">
+                  <a16:creationId xmlns:a16="http://schemas.microsoft.com/office/drawing/2014/main" id="{A0A46A15-BA06-F622-02F9-8ADB85C57AEC}"/>
+                </a:ext>
+              </a:extLst>
+            </p:cNvPr>
+            <p:cNvPicPr>
+              <a:picLocks noChangeAspect="1"/>
+            </p:cNvPicPr>
+            <p:nvPr/>
+          </p:nvPicPr>
+          <p:blipFill>
+            <a:blip r:embed="rId4"/>
+            <a:stretch>
+              <a:fillRect/>
+            </a:stretch>
+          </p:blipFill>
+          <p:spPr>
+            <a:xfrm>
+              <a:off x="2926845" y="4456890"/>
+              <a:ext cx="3943900" cy="2392061"/>
+            </a:xfrm>
+            <a:prstGeom prst="rect">
+              <a:avLst/>
+            </a:prstGeom>
+          </p:spPr>
+        </p:pic>
+        <p:sp>
+          <p:nvSpPr>
+            <p:cNvPr id="9" name="Arrow: Down 8">
+              <a:extLst>
+                <a:ext uri="{FF2B5EF4-FFF2-40B4-BE49-F238E27FC236}">
+                  <a16:creationId xmlns:a16="http://schemas.microsoft.com/office/drawing/2014/main" id="{B9F4D72F-D232-6BCD-D341-E4B1E6B1DD25}"/>
+                </a:ext>
+              </a:extLst>
+            </p:cNvPr>
+            <p:cNvSpPr/>
+            <p:nvPr/>
+          </p:nvSpPr>
+          <p:spPr>
+            <a:xfrm>
+              <a:off x="4710259" y="4033199"/>
+              <a:ext cx="377072" cy="355354"/>
+            </a:xfrm>
+            <a:prstGeom prst="downArrow">
+              <a:avLst/>
+            </a:prstGeom>
+          </p:spPr>
+          <p:style>
+            <a:lnRef idx="2">
+              <a:schemeClr val="dk1">
+                <a:shade val="15000"/>
+              </a:schemeClr>
+            </a:lnRef>
+            <a:fillRef idx="1">
+              <a:schemeClr val="dk1"/>
+            </a:fillRef>
+            <a:effectRef idx="0">
+              <a:schemeClr val="dk1"/>
+            </a:effectRef>
+            <a:fontRef idx="minor">
+              <a:schemeClr val="lt1"/>
+            </a:fontRef>
+          </p:style>
+          <p:txBody>
+            <a:bodyPr rtlCol="0" anchor="ctr"/>
+            <a:lstStyle/>
+            <a:p>
+              <a:pPr algn="ctr"/>
+              <a:endParaRPr lang="en-US"/>
+            </a:p>
+          </p:txBody>
+        </p:sp>
+      </p:grpSp>
+    </p:spTree>
+    <p:extLst>
+      <p:ext uri="{BB962C8B-B14F-4D97-AF65-F5344CB8AC3E}">
+        <p14:creationId xmlns:p14="http://schemas.microsoft.com/office/powerpoint/2010/main" val="3095838342"/>
+      </p:ext>
+    </p:extLst>
+  </p:cSld>
+  <p:clrMapOvr>
+    <a:masterClrMapping/>
+  </p:clrMapOvr>
+</p:sld>
+</file>
+
+<file path=ppt/slides/slide4.xml><?xml version="1.0" encoding="utf-8"?>
+<p:sld xmlns:a="http://schemas.openxmlformats.org/drawingml/2006/main" xmlns:r="http://schemas.openxmlformats.org/officeDocument/2006/relationships" xmlns:p="http://schemas.openxmlformats.org/presentationml/2006/main">
+  <p:cSld>
+    <p:spTree>
+      <p:nvGrpSpPr>
+        <p:cNvPr id="1" name="">
+          <a:extLst>
+            <a:ext uri="{FF2B5EF4-FFF2-40B4-BE49-F238E27FC236}">
+              <a16:creationId xmlns:a16="http://schemas.microsoft.com/office/drawing/2014/main" id="{1B857086-D847-EC5B-2154-3EC66A296777}"/>
+            </a:ext>
+          </a:extLst>
+        </p:cNvPr>
+        <p:cNvGrpSpPr/>
+        <p:nvPr/>
+      </p:nvGrpSpPr>
+      <p:grpSpPr>
+        <a:xfrm>
+          <a:off x="0" y="0"/>
+          <a:ext cx="0" cy="0"/>
+          <a:chOff x="0" y="0"/>
+          <a:chExt cx="0" cy="0"/>
+        </a:xfrm>
+      </p:grpSpPr>
+      <p:sp>
+        <p:nvSpPr>
+          <p:cNvPr id="3" name="TextBox 2">
+            <a:extLst>
+              <a:ext uri="{FF2B5EF4-FFF2-40B4-BE49-F238E27FC236}">
+                <a16:creationId xmlns:a16="http://schemas.microsoft.com/office/drawing/2014/main" id="{E8F8177E-0132-7AD5-E1B0-C386B824AABC}"/>
+              </a:ext>
+            </a:extLst>
+          </p:cNvPr>
+          <p:cNvSpPr txBox="1"/>
+          <p:nvPr/>
+        </p:nvSpPr>
+        <p:spPr>
+          <a:xfrm>
+            <a:off x="217714" y="255046"/>
+            <a:ext cx="11756571" cy="955518"/>
+          </a:xfrm>
+          <a:prstGeom prst="rect">
+            <a:avLst/>
+          </a:prstGeom>
+          <a:noFill/>
+        </p:spPr>
+        <p:txBody>
+          <a:bodyPr wrap="square">
+            <a:spAutoFit/>
+          </a:bodyPr>
+          <a:lstStyle/>
+          <a:p>
+            <a:pPr>
+              <a:lnSpc>
+                <a:spcPct val="150000"/>
+              </a:lnSpc>
+              <a:buNone/>
+            </a:pPr>
+            <a:r>
+              <a:rPr kumimoji="0" lang="en-US" altLang="en-US" sz="1300" b="1" u="none" strike="noStrike" cap="none" normalizeH="0" baseline="0">
+                <a:ln>
+                  <a:noFill/>
+                </a:ln>
+                <a:solidFill>
+                  <a:srgbClr val="00B050"/>
+                </a:solidFill>
+                <a:effectLst/>
+                <a:latin typeface="Arial" panose="020B0604020202020204" pitchFamily="34" charset="0"/>
+              </a:rPr>
+              <a:t>Təhlükəsizlik Nöqteyi-Nəzərdən</a:t>
+            </a:r>
+            <a:r>
+              <a:rPr kumimoji="0" lang="az-Latn-AZ" altLang="en-US" sz="1300" b="0" i="0" u="none" strike="noStrike" cap="none" normalizeH="0" baseline="0">
+                <a:ln>
+                  <a:noFill/>
+                </a:ln>
+                <a:solidFill>
+                  <a:schemeClr val="tx1"/>
+                </a:solidFill>
+                <a:effectLst/>
+                <a:latin typeface="Arial" panose="020B0604020202020204" pitchFamily="34" charset="0"/>
+              </a:rPr>
+              <a:t>.</a:t>
+            </a:r>
+            <a:endParaRPr lang="az-Latn-AZ" altLang="en-US" sz="1300">
+              <a:latin typeface="Arial" panose="020B0604020202020204" pitchFamily="34" charset="0"/>
+            </a:endParaRPr>
+          </a:p>
+          <a:p>
+            <a:pPr>
+              <a:lnSpc>
+                <a:spcPct val="150000"/>
+              </a:lnSpc>
+              <a:buNone/>
+            </a:pPr>
+            <a:endParaRPr lang="az-Latn-AZ" altLang="en-US" sz="1300" b="1">
+              <a:latin typeface="Arial" panose="020B0604020202020204" pitchFamily="34" charset="0"/>
+            </a:endParaRPr>
+          </a:p>
+          <a:p>
+            <a:pPr>
+              <a:lnSpc>
+                <a:spcPct val="150000"/>
+              </a:lnSpc>
+              <a:buNone/>
+            </a:pPr>
+            <a:r>
+              <a:rPr lang="az-Latn-AZ" altLang="en-US" sz="1300" b="1">
+                <a:latin typeface="Arial" panose="020B0604020202020204" pitchFamily="34" charset="0"/>
+              </a:rPr>
+              <a:t>Logout</a:t>
+            </a:r>
+            <a:r>
+              <a:rPr lang="az-Latn-AZ" altLang="en-US" sz="1300">
+                <a:latin typeface="Arial" panose="020B0604020202020204" pitchFamily="34" charset="0"/>
+              </a:rPr>
+              <a:t> </a:t>
+            </a:r>
+            <a:r>
+              <a:rPr lang="az-Latn-AZ" altLang="en-US" sz="1300" b="1">
+                <a:latin typeface="Arial" panose="020B0604020202020204" pitchFamily="34" charset="0"/>
+              </a:rPr>
+              <a:t>əməliyyatlarında</a:t>
+            </a:r>
+            <a:r>
+              <a:rPr lang="az-Latn-AZ" altLang="en-US" sz="1300">
+                <a:latin typeface="Arial" panose="020B0604020202020204" pitchFamily="34" charset="0"/>
+              </a:rPr>
+              <a:t>: Bu zaman həm sessiya məlumatları silinir, həm də yeni CSRF token yaradılır. Bu daha təhlükəsiz yanaşmadır.</a:t>
+            </a:r>
+            <a:endParaRPr kumimoji="0" lang="en-US" altLang="en-US" sz="1300" b="0" i="0" u="none" strike="noStrike" cap="none" normalizeH="0" baseline="0">
+              <a:ln>
+                <a:noFill/>
+              </a:ln>
+              <a:solidFill>
+                <a:schemeClr val="tx1"/>
+              </a:solidFill>
+              <a:effectLst/>
+              <a:latin typeface="Arial" panose="020B0604020202020204" pitchFamily="34" charset="0"/>
+            </a:endParaRPr>
+          </a:p>
+        </p:txBody>
+      </p:sp>
+      <p:pic>
+        <p:nvPicPr>
+          <p:cNvPr id="4" name="Picture 3">
+            <a:extLst>
+              <a:ext uri="{FF2B5EF4-FFF2-40B4-BE49-F238E27FC236}">
+                <a16:creationId xmlns:a16="http://schemas.microsoft.com/office/drawing/2014/main" id="{8EC72B97-6597-8149-060D-5240A5FECB43}"/>
+              </a:ext>
+            </a:extLst>
+          </p:cNvPr>
+          <p:cNvPicPr>
+            <a:picLocks noChangeAspect="1"/>
+          </p:cNvPicPr>
+          <p:nvPr/>
+        </p:nvPicPr>
+        <p:blipFill>
+          <a:blip r:embed="rId2"/>
+          <a:stretch>
+            <a:fillRect/>
+          </a:stretch>
+        </p:blipFill>
+        <p:spPr>
+          <a:xfrm>
+            <a:off x="0" y="1350125"/>
+            <a:ext cx="3305636" cy="952633"/>
+          </a:xfrm>
+          <a:prstGeom prst="rect">
+            <a:avLst/>
+          </a:prstGeom>
+        </p:spPr>
+      </p:pic>
+    </p:spTree>
+    <p:extLst>
+      <p:ext uri="{BB962C8B-B14F-4D97-AF65-F5344CB8AC3E}">
+        <p14:creationId xmlns:p14="http://schemas.microsoft.com/office/powerpoint/2010/main" val="3588139137"/>
+      </p:ext>
+    </p:extLst>
+  </p:cSld>
+  <p:clrMapOvr>
+    <a:masterClrMapping/>
+  </p:clrMapOvr>
+</p:sld>
+</file>
+
+<file path=ppt/slides/slide5.xml><?xml version="1.0" encoding="utf-8"?>
+<p:sld xmlns:a="http://schemas.openxmlformats.org/drawingml/2006/main" xmlns:r="http://schemas.openxmlformats.org/officeDocument/2006/relationships" xmlns:p="http://schemas.openxmlformats.org/presentationml/2006/main">
+  <p:cSld>
+    <p:spTree>
+      <p:nvGrpSpPr>
+        <p:cNvPr id="1" name="">
+          <a:extLst>
+            <a:ext uri="{FF2B5EF4-FFF2-40B4-BE49-F238E27FC236}">
+              <a16:creationId xmlns:a16="http://schemas.microsoft.com/office/drawing/2014/main" id="{40007143-95A0-820A-67BC-CB50D5092F18}"/>
+            </a:ext>
+          </a:extLst>
+        </p:cNvPr>
+        <p:cNvGrpSpPr/>
+        <p:nvPr/>
+      </p:nvGrpSpPr>
+      <p:grpSpPr>
+        <a:xfrm>
+          <a:off x="0" y="0"/>
+          <a:ext cx="0" cy="0"/>
+          <a:chOff x="0" y="0"/>
+          <a:chExt cx="0" cy="0"/>
+        </a:xfrm>
+      </p:grpSpPr>
+      <p:sp>
+        <p:nvSpPr>
+          <p:cNvPr id="3" name="TextBox 2">
+            <a:extLst>
+              <a:ext uri="{FF2B5EF4-FFF2-40B4-BE49-F238E27FC236}">
+                <a16:creationId xmlns:a16="http://schemas.microsoft.com/office/drawing/2014/main" id="{3F32F36C-5FA7-FED5-1A45-DAAF4F1CA288}"/>
+              </a:ext>
+            </a:extLst>
+          </p:cNvPr>
+          <p:cNvSpPr txBox="1"/>
+          <p:nvPr/>
+        </p:nvSpPr>
+        <p:spPr>
+          <a:xfrm>
+            <a:off x="217714" y="255046"/>
+            <a:ext cx="11756571" cy="3956339"/>
+          </a:xfrm>
+          <a:prstGeom prst="rect">
+            <a:avLst/>
+          </a:prstGeom>
+          <a:noFill/>
+        </p:spPr>
+        <p:txBody>
+          <a:bodyPr wrap="square">
+            <a:spAutoFit/>
+          </a:bodyPr>
+          <a:lstStyle/>
+          <a:p>
+            <a:pPr>
+              <a:lnSpc>
+                <a:spcPct val="150000"/>
+              </a:lnSpc>
+              <a:buNone/>
+            </a:pPr>
+            <a:r>
+              <a:rPr kumimoji="0" lang="en-US" altLang="en-US" sz="1300" b="1" i="0" u="none" strike="noStrike" cap="none" normalizeH="0" baseline="0">
+                <a:ln>
+                  <a:noFill/>
+                </a:ln>
+                <a:solidFill>
+                  <a:srgbClr val="FF0000"/>
+                </a:solidFill>
+                <a:effectLst/>
+                <a:latin typeface="Arial" panose="020B0604020202020204" pitchFamily="34" charset="0"/>
+              </a:rPr>
+              <a:t>invalidate()</a:t>
+            </a:r>
+            <a:r>
+              <a:rPr kumimoji="0" lang="en-US" altLang="en-US" sz="1300" b="0" i="0" u="none" strike="noStrike" cap="none" normalizeH="0" baseline="0">
+                <a:ln>
+                  <a:noFill/>
+                </a:ln>
+                <a:solidFill>
+                  <a:schemeClr val="tx1"/>
+                </a:solidFill>
+                <a:effectLst/>
+                <a:latin typeface="Arial" panose="020B0604020202020204" pitchFamily="34" charset="0"/>
+              </a:rPr>
+              <a:t> Laravel sessiyasını tamamilə sıfırlayır:</a:t>
+            </a:r>
+            <a:endParaRPr kumimoji="0" lang="az-Latn-AZ" altLang="en-US" sz="1300" b="0" i="0" u="none" strike="noStrike" cap="none" normalizeH="0" baseline="0">
+              <a:ln>
+                <a:noFill/>
+              </a:ln>
+              <a:solidFill>
+                <a:schemeClr val="tx1"/>
+              </a:solidFill>
+              <a:effectLst/>
+              <a:latin typeface="Arial" panose="020B0604020202020204" pitchFamily="34" charset="0"/>
+            </a:endParaRPr>
+          </a:p>
+          <a:p>
+            <a:pPr>
+              <a:lnSpc>
+                <a:spcPct val="150000"/>
+              </a:lnSpc>
+              <a:buNone/>
+            </a:pPr>
+            <a:endParaRPr kumimoji="0" lang="en-US" altLang="en-US" sz="1300" b="0" i="0" u="none" strike="noStrike" cap="none" normalizeH="0" baseline="0">
+              <a:ln>
+                <a:noFill/>
+              </a:ln>
+              <a:solidFill>
+                <a:schemeClr val="tx1"/>
+              </a:solidFill>
+              <a:effectLst/>
+              <a:latin typeface="Arial" panose="020B0604020202020204" pitchFamily="34" charset="0"/>
+            </a:endParaRPr>
+          </a:p>
+          <a:p>
+            <a:pPr marL="285750" indent="-285750">
+              <a:lnSpc>
+                <a:spcPct val="150000"/>
+              </a:lnSpc>
+              <a:buFont typeface="Arial" panose="020B0604020202020204" pitchFamily="34" charset="0"/>
+              <a:buChar char="•"/>
+            </a:pPr>
+            <a:r>
+              <a:rPr kumimoji="0" lang="en-US" altLang="en-US" sz="1300" b="0" i="0" u="none" strike="noStrike" cap="none" normalizeH="0" baseline="0">
+                <a:ln>
+                  <a:noFill/>
+                </a:ln>
+                <a:solidFill>
+                  <a:schemeClr val="tx1"/>
+                </a:solidFill>
+                <a:effectLst/>
+                <a:latin typeface="Arial" panose="020B0604020202020204" pitchFamily="34" charset="0"/>
+              </a:rPr>
+              <a:t>Bütün sessiya məlumatlarını silir (yəni </a:t>
+            </a:r>
+            <a:r>
+              <a:rPr kumimoji="0" lang="en-US" altLang="en-US" sz="1300" b="1" i="0" u="none" strike="noStrike" cap="none" normalizeH="0" baseline="0">
+                <a:ln>
+                  <a:noFill/>
+                </a:ln>
+                <a:solidFill>
+                  <a:srgbClr val="FF0000"/>
+                </a:solidFill>
+                <a:effectLst/>
+                <a:latin typeface="Arial" panose="020B0604020202020204" pitchFamily="34" charset="0"/>
+              </a:rPr>
+              <a:t>flush() </a:t>
+            </a:r>
+            <a:r>
+              <a:rPr kumimoji="0" lang="en-US" altLang="en-US" sz="1300" b="0" i="0" u="none" strike="noStrike" cap="none" normalizeH="0" baseline="0">
+                <a:ln>
+                  <a:noFill/>
+                </a:ln>
+                <a:solidFill>
+                  <a:schemeClr val="tx1"/>
+                </a:solidFill>
+                <a:effectLst/>
+                <a:latin typeface="Arial" panose="020B0604020202020204" pitchFamily="34" charset="0"/>
+              </a:rPr>
+              <a:t>kimi).</a:t>
+            </a:r>
+          </a:p>
+          <a:p>
+            <a:pPr marL="285750" indent="-285750">
+              <a:lnSpc>
+                <a:spcPct val="150000"/>
+              </a:lnSpc>
+              <a:buFont typeface="Arial" panose="020B0604020202020204" pitchFamily="34" charset="0"/>
+              <a:buChar char="•"/>
+            </a:pPr>
+            <a:r>
+              <a:rPr kumimoji="0" lang="en-US" altLang="en-US" sz="1300" b="0" i="0" u="none" strike="noStrike" cap="none" normalizeH="0" baseline="0">
+                <a:ln>
+                  <a:noFill/>
+                </a:ln>
+                <a:solidFill>
+                  <a:schemeClr val="tx1"/>
+                </a:solidFill>
+                <a:effectLst/>
+                <a:latin typeface="Arial" panose="020B0604020202020204" pitchFamily="34" charset="0"/>
+              </a:rPr>
+              <a:t>Sessiyanın </a:t>
+            </a:r>
+            <a:r>
+              <a:rPr kumimoji="0" lang="en-US" altLang="en-US" sz="1300" b="1" i="0" u="none" strike="noStrike" cap="none" normalizeH="0" baseline="0">
+                <a:ln>
+                  <a:noFill/>
+                </a:ln>
+                <a:solidFill>
+                  <a:schemeClr val="tx1"/>
+                </a:solidFill>
+                <a:effectLst/>
+                <a:latin typeface="Arial" panose="020B0604020202020204" pitchFamily="34" charset="0"/>
+              </a:rPr>
+              <a:t>ID</a:t>
+            </a:r>
+            <a:r>
+              <a:rPr kumimoji="0" lang="en-US" altLang="en-US" sz="1300" b="0" i="0" u="none" strike="noStrike" cap="none" normalizeH="0" baseline="0">
+                <a:ln>
+                  <a:noFill/>
+                </a:ln>
+                <a:solidFill>
+                  <a:schemeClr val="tx1"/>
+                </a:solidFill>
+                <a:effectLst/>
+                <a:latin typeface="Arial" panose="020B0604020202020204" pitchFamily="34" charset="0"/>
+              </a:rPr>
+              <a:t>-sini dəyişir – yəni yeni bir sessiya açar (</a:t>
+            </a:r>
+            <a:r>
+              <a:rPr kumimoji="0" lang="en-US" altLang="en-US" sz="1300" b="1" i="0" u="none" strike="noStrike" cap="none" normalizeH="0" baseline="0">
+                <a:ln>
+                  <a:noFill/>
+                </a:ln>
+                <a:solidFill>
+                  <a:schemeClr val="tx1"/>
+                </a:solidFill>
+                <a:effectLst/>
+                <a:latin typeface="Arial" panose="020B0604020202020204" pitchFamily="34" charset="0"/>
+              </a:rPr>
+              <a:t>ID</a:t>
+            </a:r>
+            <a:r>
+              <a:rPr kumimoji="0" lang="en-US" altLang="en-US" sz="1300" b="0" i="0" u="none" strike="noStrike" cap="none" normalizeH="0" baseline="0">
+                <a:ln>
+                  <a:noFill/>
+                </a:ln>
+                <a:solidFill>
+                  <a:schemeClr val="tx1"/>
+                </a:solidFill>
+                <a:effectLst/>
+                <a:latin typeface="Arial" panose="020B0604020202020204" pitchFamily="34" charset="0"/>
+              </a:rPr>
+              <a:t>) yaradır.</a:t>
+            </a:r>
+            <a:endParaRPr kumimoji="0" lang="az-Latn-AZ" altLang="en-US" sz="1300" b="0" i="0" u="none" strike="noStrike" cap="none" normalizeH="0" baseline="0">
+              <a:ln>
+                <a:noFill/>
+              </a:ln>
+              <a:solidFill>
+                <a:schemeClr val="tx1"/>
+              </a:solidFill>
+              <a:effectLst/>
+              <a:latin typeface="Arial" panose="020B0604020202020204" pitchFamily="34" charset="0"/>
+            </a:endParaRPr>
+          </a:p>
+          <a:p>
+            <a:pPr>
+              <a:lnSpc>
+                <a:spcPct val="150000"/>
+              </a:lnSpc>
+              <a:buNone/>
+            </a:pPr>
+            <a:endParaRPr lang="az-Latn-AZ" altLang="en-US" sz="1300">
+              <a:latin typeface="Arial" panose="020B0604020202020204" pitchFamily="34" charset="0"/>
+            </a:endParaRPr>
+          </a:p>
+          <a:p>
+            <a:pPr>
+              <a:lnSpc>
+                <a:spcPct val="150000"/>
+              </a:lnSpc>
+              <a:buNone/>
+            </a:pPr>
+            <a:endParaRPr kumimoji="0" lang="az-Latn-AZ" altLang="en-US" sz="1300" b="0" i="0" u="none" strike="noStrike" cap="none" normalizeH="0" baseline="0">
+              <a:ln>
+                <a:noFill/>
+              </a:ln>
+              <a:solidFill>
+                <a:schemeClr val="tx1"/>
+              </a:solidFill>
+              <a:effectLst/>
+              <a:latin typeface="Arial" panose="020B0604020202020204" pitchFamily="34" charset="0"/>
+            </a:endParaRPr>
+          </a:p>
+          <a:p>
+            <a:pPr>
+              <a:lnSpc>
+                <a:spcPct val="150000"/>
+              </a:lnSpc>
+              <a:buNone/>
+            </a:pPr>
+            <a:r>
+              <a:rPr kumimoji="0" lang="en-US" altLang="en-US" sz="1300" b="1" i="0" u="none" strike="noStrike" cap="none" normalizeH="0" baseline="0">
+                <a:ln>
+                  <a:noFill/>
+                </a:ln>
+                <a:solidFill>
+                  <a:schemeClr val="tx1"/>
+                </a:solidFill>
+                <a:effectLst/>
+                <a:latin typeface="Arial" panose="020B0604020202020204" pitchFamily="34" charset="0"/>
+              </a:rPr>
+              <a:t>Niyə invalidate() istifadə olunur?</a:t>
+            </a:r>
+          </a:p>
+          <a:p>
+            <a:pPr marL="285750" indent="-285750">
+              <a:lnSpc>
+                <a:spcPct val="150000"/>
+              </a:lnSpc>
+              <a:buFont typeface="Arial" panose="020B0604020202020204" pitchFamily="34" charset="0"/>
+              <a:buChar char="•"/>
+            </a:pPr>
+            <a:r>
+              <a:rPr kumimoji="0" lang="en-US" altLang="en-US" sz="1300" b="0" i="0" u="none" strike="noStrike" cap="none" normalizeH="0" baseline="0">
+                <a:ln>
+                  <a:noFill/>
+                </a:ln>
+                <a:solidFill>
+                  <a:schemeClr val="tx1"/>
+                </a:solidFill>
+                <a:effectLst/>
+                <a:latin typeface="Arial" panose="020B0604020202020204" pitchFamily="34" charset="0"/>
+              </a:rPr>
+              <a:t>Bu metod əsasən istifadəçini çıxış etdirmək (</a:t>
+            </a:r>
+            <a:r>
+              <a:rPr kumimoji="0" lang="en-US" altLang="en-US" sz="1300" b="1" i="0" u="none" strike="noStrike" cap="none" normalizeH="0" baseline="0">
+                <a:ln>
+                  <a:noFill/>
+                </a:ln>
+                <a:solidFill>
+                  <a:schemeClr val="tx1"/>
+                </a:solidFill>
+                <a:effectLst/>
+                <a:latin typeface="Arial" panose="020B0604020202020204" pitchFamily="34" charset="0"/>
+              </a:rPr>
+              <a:t>logout</a:t>
+            </a:r>
+            <a:r>
+              <a:rPr kumimoji="0" lang="en-US" altLang="en-US" sz="1300" b="0" i="0" u="none" strike="noStrike" cap="none" normalizeH="0" baseline="0">
+                <a:ln>
+                  <a:noFill/>
+                </a:ln>
+                <a:solidFill>
+                  <a:schemeClr val="tx1"/>
+                </a:solidFill>
+                <a:effectLst/>
+                <a:latin typeface="Arial" panose="020B0604020202020204" pitchFamily="34" charset="0"/>
+              </a:rPr>
+              <a:t>) zamanı istifadə olunur. Çünki təkcə məlumatları silmək kifayət deyil — sessiyanın özünü də sıfırlamaq lazımdır.</a:t>
+            </a:r>
+            <a:endParaRPr kumimoji="0" lang="az-Latn-AZ" altLang="en-US" sz="1300" b="0" i="0" u="none" strike="noStrike" cap="none" normalizeH="0" baseline="0">
+              <a:ln>
+                <a:noFill/>
+              </a:ln>
+              <a:solidFill>
+                <a:schemeClr val="tx1"/>
+              </a:solidFill>
+              <a:effectLst/>
+              <a:latin typeface="Arial" panose="020B0604020202020204" pitchFamily="34" charset="0"/>
+            </a:endParaRPr>
+          </a:p>
+          <a:p>
+            <a:pPr>
+              <a:lnSpc>
+                <a:spcPct val="150000"/>
+              </a:lnSpc>
+              <a:buNone/>
+            </a:pPr>
+            <a:endParaRPr lang="az-Latn-AZ" altLang="en-US" sz="1300">
+              <a:latin typeface="Arial" panose="020B0604020202020204" pitchFamily="34" charset="0"/>
+            </a:endParaRPr>
+          </a:p>
+          <a:p>
+            <a:pPr>
+              <a:lnSpc>
+                <a:spcPct val="150000"/>
+              </a:lnSpc>
+              <a:buNone/>
+            </a:pPr>
+            <a:endParaRPr kumimoji="0" lang="az-Latn-AZ" altLang="en-US" sz="1300" b="0" i="0" u="none" strike="noStrike" cap="none" normalizeH="0" baseline="0">
+              <a:ln>
+                <a:noFill/>
+              </a:ln>
+              <a:solidFill>
+                <a:schemeClr val="tx1"/>
+              </a:solidFill>
+              <a:effectLst/>
+              <a:latin typeface="Arial" panose="020B0604020202020204" pitchFamily="34" charset="0"/>
+            </a:endParaRPr>
+          </a:p>
+          <a:p>
+            <a:pPr>
+              <a:lnSpc>
+                <a:spcPct val="150000"/>
+              </a:lnSpc>
+              <a:buNone/>
+            </a:pPr>
+            <a:r>
+              <a:rPr lang="az-Latn-AZ" altLang="en-US" sz="1300" b="1">
+                <a:latin typeface="Arial" panose="020B0604020202020204" pitchFamily="34" charset="0"/>
+              </a:rPr>
+              <a:t>flush() </a:t>
+            </a:r>
+            <a:r>
+              <a:rPr lang="az-Latn-AZ" altLang="en-US" sz="1300">
+                <a:latin typeface="Arial" panose="020B0604020202020204" pitchFamily="34" charset="0"/>
+              </a:rPr>
+              <a:t>vs </a:t>
+            </a:r>
+            <a:r>
+              <a:rPr lang="az-Latn-AZ" altLang="en-US" sz="1300" b="1">
+                <a:latin typeface="Arial" panose="020B0604020202020204" pitchFamily="34" charset="0"/>
+              </a:rPr>
+              <a:t>invalidate() </a:t>
+            </a:r>
+            <a:r>
+              <a:rPr lang="az-Latn-AZ" altLang="en-US" sz="1300">
+                <a:latin typeface="Arial" panose="020B0604020202020204" pitchFamily="34" charset="0"/>
+              </a:rPr>
+              <a:t>– Fərq nədir?</a:t>
+            </a:r>
+          </a:p>
+          <a:p>
+            <a:pPr>
+              <a:lnSpc>
+                <a:spcPct val="150000"/>
+              </a:lnSpc>
+              <a:buNone/>
+            </a:pPr>
+            <a:endParaRPr kumimoji="0" lang="en-US" altLang="en-US" sz="1300" b="0" i="0" u="none" strike="noStrike" cap="none" normalizeH="0" baseline="0">
+              <a:ln>
+                <a:noFill/>
+              </a:ln>
+              <a:solidFill>
+                <a:schemeClr val="tx1"/>
+              </a:solidFill>
+              <a:effectLst/>
+              <a:latin typeface="Arial" panose="020B0604020202020204" pitchFamily="34" charset="0"/>
+            </a:endParaRPr>
+          </a:p>
+        </p:txBody>
+      </p:sp>
+      <p:graphicFrame>
+        <p:nvGraphicFramePr>
+          <p:cNvPr id="2" name="Table 1">
+            <a:extLst>
+              <a:ext uri="{FF2B5EF4-FFF2-40B4-BE49-F238E27FC236}">
+                <a16:creationId xmlns:a16="http://schemas.microsoft.com/office/drawing/2014/main" id="{8CDEDBF3-9E31-6B4C-6B8A-D407A09F24EA}"/>
+              </a:ext>
+            </a:extLst>
+          </p:cNvPr>
+          <p:cNvGraphicFramePr>
+            <a:graphicFrameLocks noGrp="1"/>
+          </p:cNvGraphicFramePr>
+          <p:nvPr>
+            <p:extLst>
+              <p:ext uri="{D42A27DB-BD31-4B8C-83A1-F6EECF244321}">
+                <p14:modId xmlns:p14="http://schemas.microsoft.com/office/powerpoint/2010/main" val="2752100686"/>
+              </p:ext>
+            </p:extLst>
+          </p:nvPr>
+        </p:nvGraphicFramePr>
+        <p:xfrm>
+          <a:off x="217714" y="4074823"/>
+          <a:ext cx="10515600" cy="1097280"/>
+        </p:xfrm>
+        <a:graphic>
+          <a:graphicData uri="http://schemas.openxmlformats.org/drawingml/2006/table">
+            <a:tbl>
+              <a:tblPr/>
+              <a:tblGrid>
+                <a:gridCol w="2628900">
+                  <a:extLst>
+                    <a:ext uri="{9D8B030D-6E8A-4147-A177-3AD203B41FA5}">
+                      <a16:colId xmlns:a16="http://schemas.microsoft.com/office/drawing/2014/main" val="551880956"/>
+                    </a:ext>
+                  </a:extLst>
+                </a:gridCol>
+                <a:gridCol w="2628900">
+                  <a:extLst>
+                    <a:ext uri="{9D8B030D-6E8A-4147-A177-3AD203B41FA5}">
+                      <a16:colId xmlns:a16="http://schemas.microsoft.com/office/drawing/2014/main" val="3555932822"/>
+                    </a:ext>
+                  </a:extLst>
+                </a:gridCol>
+                <a:gridCol w="2628900">
+                  <a:extLst>
+                    <a:ext uri="{9D8B030D-6E8A-4147-A177-3AD203B41FA5}">
+                      <a16:colId xmlns:a16="http://schemas.microsoft.com/office/drawing/2014/main" val="4247730054"/>
+                    </a:ext>
+                  </a:extLst>
+                </a:gridCol>
+                <a:gridCol w="2628900">
+                  <a:extLst>
+                    <a:ext uri="{9D8B030D-6E8A-4147-A177-3AD203B41FA5}">
+                      <a16:colId xmlns:a16="http://schemas.microsoft.com/office/drawing/2014/main" val="3287018654"/>
+                    </a:ext>
+                  </a:extLst>
+                </a:gridCol>
+              </a:tblGrid>
+              <a:tr h="0">
+                <a:tc>
+                  <a:txBody>
+                    <a:bodyPr/>
+                    <a:lstStyle/>
+                    <a:p>
+                      <a:r>
+                        <a:rPr lang="en-US" b="1"/>
+                        <a:t>Metod</a:t>
+                      </a:r>
+                    </a:p>
+                  </a:txBody>
+                  <a:tcPr anchor="ctr">
+                    <a:lnL w="12700" cap="flat" cmpd="sng" algn="ctr">
+                      <a:solidFill>
+                        <a:schemeClr val="tx1"/>
+                      </a:solidFill>
+                      <a:prstDash val="solid"/>
+                      <a:round/>
+                      <a:headEnd type="none" w="med" len="med"/>
+                      <a:tailEnd type="none" w="med" len="med"/>
+                    </a:lnL>
+                    <a:lnR w="12700" cap="flat" cmpd="sng" algn="ctr">
+                      <a:solidFill>
+                        <a:schemeClr val="tx1"/>
+                      </a:solidFill>
+                      <a:prstDash val="solid"/>
+                      <a:round/>
+                      <a:headEnd type="none" w="med" len="med"/>
+                      <a:tailEnd type="none" w="med" len="med"/>
+                    </a:lnR>
+                    <a:lnT w="12700" cap="flat" cmpd="sng" algn="ctr">
+                      <a:solidFill>
+                        <a:schemeClr val="tx1"/>
+                      </a:solidFill>
+                      <a:prstDash val="solid"/>
+                      <a:round/>
+                      <a:headEnd type="none" w="med" len="med"/>
+                      <a:tailEnd type="none" w="med" len="med"/>
+                    </a:lnT>
+                    <a:lnB w="12700" cap="flat" cmpd="sng" algn="ctr">
+                      <a:solidFill>
+                        <a:schemeClr val="tx1"/>
+                      </a:solidFill>
+                      <a:prstDash val="solid"/>
+                      <a:round/>
+                      <a:headEnd type="none" w="med" len="med"/>
+                      <a:tailEnd type="none" w="med" len="med"/>
+                    </a:lnB>
+                    <a:solidFill>
+                      <a:schemeClr val="accent2"/>
+                    </a:solidFill>
+                  </a:tcPr>
+                </a:tc>
+                <a:tc>
+                  <a:txBody>
+                    <a:bodyPr/>
+                    <a:lstStyle/>
+                    <a:p>
+                      <a:r>
+                        <a:rPr lang="en-US" b="1"/>
+                        <a:t>Məlumatları silir</a:t>
+                      </a:r>
+                    </a:p>
+                  </a:txBody>
+                  <a:tcPr anchor="ctr">
+                    <a:lnL w="12700" cap="flat" cmpd="sng" algn="ctr">
+                      <a:solidFill>
+                        <a:schemeClr val="tx1"/>
+                      </a:solidFill>
+                      <a:prstDash val="solid"/>
+                      <a:round/>
+                      <a:headEnd type="none" w="med" len="med"/>
+                      <a:tailEnd type="none" w="med" len="med"/>
+                    </a:lnL>
+                    <a:lnR w="12700" cap="flat" cmpd="sng" algn="ctr">
+                      <a:solidFill>
+                        <a:schemeClr val="tx1"/>
+                      </a:solidFill>
+                      <a:prstDash val="solid"/>
+                      <a:round/>
+                      <a:headEnd type="none" w="med" len="med"/>
+                      <a:tailEnd type="none" w="med" len="med"/>
+                    </a:lnR>
+                    <a:lnT w="12700" cap="flat" cmpd="sng" algn="ctr">
+                      <a:solidFill>
+                        <a:schemeClr val="tx1"/>
+                      </a:solidFill>
+                      <a:prstDash val="solid"/>
+                      <a:round/>
+                      <a:headEnd type="none" w="med" len="med"/>
+                      <a:tailEnd type="none" w="med" len="med"/>
+                    </a:lnT>
+                    <a:lnB w="12700" cap="flat" cmpd="sng" algn="ctr">
+                      <a:solidFill>
+                        <a:schemeClr val="tx1"/>
+                      </a:solidFill>
+                      <a:prstDash val="solid"/>
+                      <a:round/>
+                      <a:headEnd type="none" w="med" len="med"/>
+                      <a:tailEnd type="none" w="med" len="med"/>
+                    </a:lnB>
+                    <a:solidFill>
+                      <a:schemeClr val="accent2"/>
+                    </a:solidFill>
+                  </a:tcPr>
+                </a:tc>
+                <a:tc>
+                  <a:txBody>
+                    <a:bodyPr/>
+                    <a:lstStyle/>
+                    <a:p>
+                      <a:r>
+                        <a:rPr lang="en-US" b="1"/>
+                        <a:t>Sessiya ID dəyişir?</a:t>
+                      </a:r>
+                    </a:p>
+                  </a:txBody>
+                  <a:tcPr anchor="ctr">
+                    <a:lnL w="12700" cap="flat" cmpd="sng" algn="ctr">
+                      <a:solidFill>
+                        <a:schemeClr val="tx1"/>
+                      </a:solidFill>
+                      <a:prstDash val="solid"/>
+                      <a:round/>
+                      <a:headEnd type="none" w="med" len="med"/>
+                      <a:tailEnd type="none" w="med" len="med"/>
+                    </a:lnL>
+                    <a:lnR w="12700" cap="flat" cmpd="sng" algn="ctr">
+                      <a:solidFill>
+                        <a:schemeClr val="tx1"/>
+                      </a:solidFill>
+                      <a:prstDash val="solid"/>
+                      <a:round/>
+                      <a:headEnd type="none" w="med" len="med"/>
+                      <a:tailEnd type="none" w="med" len="med"/>
+                    </a:lnR>
+                    <a:lnT w="12700" cap="flat" cmpd="sng" algn="ctr">
+                      <a:solidFill>
+                        <a:schemeClr val="tx1"/>
+                      </a:solidFill>
+                      <a:prstDash val="solid"/>
+                      <a:round/>
+                      <a:headEnd type="none" w="med" len="med"/>
+                      <a:tailEnd type="none" w="med" len="med"/>
+                    </a:lnT>
+                    <a:lnB w="12700" cap="flat" cmpd="sng" algn="ctr">
+                      <a:solidFill>
+                        <a:schemeClr val="tx1"/>
+                      </a:solidFill>
+                      <a:prstDash val="solid"/>
+                      <a:round/>
+                      <a:headEnd type="none" w="med" len="med"/>
+                      <a:tailEnd type="none" w="med" len="med"/>
+                    </a:lnB>
+                    <a:solidFill>
+                      <a:schemeClr val="accent2"/>
+                    </a:solidFill>
+                  </a:tcPr>
+                </a:tc>
+                <a:tc>
+                  <a:txBody>
+                    <a:bodyPr/>
+                    <a:lstStyle/>
+                    <a:p>
+                      <a:r>
+                        <a:rPr lang="en-US" b="1"/>
+                        <a:t>İstifadə sahəsi</a:t>
+                      </a:r>
+                    </a:p>
+                  </a:txBody>
+                  <a:tcPr anchor="ctr">
+                    <a:lnL w="12700" cap="flat" cmpd="sng" algn="ctr">
+                      <a:solidFill>
+                        <a:schemeClr val="tx1"/>
+                      </a:solidFill>
+                      <a:prstDash val="solid"/>
+                      <a:round/>
+                      <a:headEnd type="none" w="med" len="med"/>
+                      <a:tailEnd type="none" w="med" len="med"/>
+                    </a:lnL>
+                    <a:lnR w="12700" cap="flat" cmpd="sng" algn="ctr">
+                      <a:solidFill>
+                        <a:schemeClr val="tx1"/>
+                      </a:solidFill>
+                      <a:prstDash val="solid"/>
+                      <a:round/>
+                      <a:headEnd type="none" w="med" len="med"/>
+                      <a:tailEnd type="none" w="med" len="med"/>
+                    </a:lnR>
+                    <a:lnT w="12700" cap="flat" cmpd="sng" algn="ctr">
+                      <a:solidFill>
+                        <a:schemeClr val="tx1"/>
+                      </a:solidFill>
+                      <a:prstDash val="solid"/>
+                      <a:round/>
+                      <a:headEnd type="none" w="med" len="med"/>
+                      <a:tailEnd type="none" w="med" len="med"/>
+                    </a:lnT>
+                    <a:lnB w="12700" cap="flat" cmpd="sng" algn="ctr">
+                      <a:solidFill>
+                        <a:schemeClr val="tx1"/>
+                      </a:solidFill>
+                      <a:prstDash val="solid"/>
+                      <a:round/>
+                      <a:headEnd type="none" w="med" len="med"/>
+                      <a:tailEnd type="none" w="med" len="med"/>
+                    </a:lnB>
+                    <a:solidFill>
+                      <a:schemeClr val="accent2"/>
+                    </a:solidFill>
+                  </a:tcPr>
+                </a:tc>
+                <a:extLst>
+                  <a:ext uri="{0D108BD9-81ED-4DB2-BD59-A6C34878D82A}">
+                    <a16:rowId xmlns:a16="http://schemas.microsoft.com/office/drawing/2014/main" val="4077781756"/>
+                  </a:ext>
+                </a:extLst>
+              </a:tr>
+              <a:tr h="0">
+                <a:tc>
+                  <a:txBody>
+                    <a:bodyPr/>
+                    <a:lstStyle/>
+                    <a:p>
+                      <a:r>
+                        <a:rPr lang="en-US"/>
+                        <a:t>flush()</a:t>
+                      </a:r>
+                    </a:p>
+                  </a:txBody>
+                  <a:tcPr anchor="ctr">
+                    <a:lnL w="12700" cap="flat" cmpd="sng" algn="ctr">
+                      <a:solidFill>
+                        <a:schemeClr val="tx1"/>
+                      </a:solidFill>
+                      <a:prstDash val="solid"/>
+                      <a:round/>
+                      <a:headEnd type="none" w="med" len="med"/>
+                      <a:tailEnd type="none" w="med" len="med"/>
+                    </a:lnL>
+                    <a:lnR w="12700" cap="flat" cmpd="sng" algn="ctr">
+                      <a:solidFill>
+                        <a:schemeClr val="tx1"/>
+                      </a:solidFill>
+                      <a:prstDash val="solid"/>
+                      <a:round/>
+                      <a:headEnd type="none" w="med" len="med"/>
+                      <a:tailEnd type="none" w="med" len="med"/>
+                    </a:lnR>
+                    <a:lnT w="12700" cap="flat" cmpd="sng" algn="ctr">
+                      <a:solidFill>
+                        <a:schemeClr val="tx1"/>
+                      </a:solidFill>
+                      <a:prstDash val="solid"/>
+                      <a:round/>
+                      <a:headEnd type="none" w="med" len="med"/>
+                      <a:tailEnd type="none" w="med" len="med"/>
+                    </a:lnT>
+                    <a:lnB w="12700" cap="flat" cmpd="sng" algn="ctr">
+                      <a:solidFill>
+                        <a:schemeClr val="tx1"/>
+                      </a:solidFill>
+                      <a:prstDash val="solid"/>
+                      <a:round/>
+                      <a:headEnd type="none" w="med" len="med"/>
+                      <a:tailEnd type="none" w="med" len="med"/>
+                    </a:lnB>
+                    <a:noFill/>
+                  </a:tcPr>
+                </a:tc>
+                <a:tc>
+                  <a:txBody>
+                    <a:bodyPr/>
+                    <a:lstStyle/>
+                    <a:p>
+                      <a:r>
+                        <a:rPr lang="en-US"/>
+                        <a:t>✅ Bəli</a:t>
+                      </a:r>
+                    </a:p>
+                  </a:txBody>
+                  <a:tcPr anchor="ctr">
+                    <a:lnL w="12700" cap="flat" cmpd="sng" algn="ctr">
+                      <a:solidFill>
+                        <a:schemeClr val="tx1"/>
+                      </a:solidFill>
+                      <a:prstDash val="solid"/>
+                      <a:round/>
+                      <a:headEnd type="none" w="med" len="med"/>
+                      <a:tailEnd type="none" w="med" len="med"/>
+                    </a:lnL>
+                    <a:lnR w="12700" cap="flat" cmpd="sng" algn="ctr">
+                      <a:solidFill>
+                        <a:schemeClr val="tx1"/>
+                      </a:solidFill>
+                      <a:prstDash val="solid"/>
+                      <a:round/>
+                      <a:headEnd type="none" w="med" len="med"/>
+                      <a:tailEnd type="none" w="med" len="med"/>
+                    </a:lnR>
+                    <a:lnT w="12700" cap="flat" cmpd="sng" algn="ctr">
+                      <a:solidFill>
+                        <a:schemeClr val="tx1"/>
+                      </a:solidFill>
+                      <a:prstDash val="solid"/>
+                      <a:round/>
+                      <a:headEnd type="none" w="med" len="med"/>
+                      <a:tailEnd type="none" w="med" len="med"/>
+                    </a:lnT>
+                    <a:lnB w="12700" cap="flat" cmpd="sng" algn="ctr">
+                      <a:solidFill>
+                        <a:schemeClr val="tx1"/>
+                      </a:solidFill>
+                      <a:prstDash val="solid"/>
+                      <a:round/>
+                      <a:headEnd type="none" w="med" len="med"/>
+                      <a:tailEnd type="none" w="med" len="med"/>
+                    </a:lnB>
+                    <a:noFill/>
+                  </a:tcPr>
+                </a:tc>
+                <a:tc>
+                  <a:txBody>
+                    <a:bodyPr/>
+                    <a:lstStyle/>
+                    <a:p>
+                      <a:r>
+                        <a:rPr lang="en-US"/>
+                        <a:t>❌ Xeyr</a:t>
+                      </a:r>
+                    </a:p>
+                  </a:txBody>
+                  <a:tcPr anchor="ctr">
+                    <a:lnL w="12700" cap="flat" cmpd="sng" algn="ctr">
+                      <a:solidFill>
+                        <a:schemeClr val="tx1"/>
+                      </a:solidFill>
+                      <a:prstDash val="solid"/>
+                      <a:round/>
+                      <a:headEnd type="none" w="med" len="med"/>
+                      <a:tailEnd type="none" w="med" len="med"/>
+                    </a:lnL>
+                    <a:lnR w="12700" cap="flat" cmpd="sng" algn="ctr">
+                      <a:solidFill>
+                        <a:schemeClr val="tx1"/>
+                      </a:solidFill>
+                      <a:prstDash val="solid"/>
+                      <a:round/>
+                      <a:headEnd type="none" w="med" len="med"/>
+                      <a:tailEnd type="none" w="med" len="med"/>
+                    </a:lnR>
+                    <a:lnT w="12700" cap="flat" cmpd="sng" algn="ctr">
+                      <a:solidFill>
+                        <a:schemeClr val="tx1"/>
+                      </a:solidFill>
+                      <a:prstDash val="solid"/>
+                      <a:round/>
+                      <a:headEnd type="none" w="med" len="med"/>
+                      <a:tailEnd type="none" w="med" len="med"/>
+                    </a:lnT>
+                    <a:lnB w="12700" cap="flat" cmpd="sng" algn="ctr">
+                      <a:solidFill>
+                        <a:schemeClr val="tx1"/>
+                      </a:solidFill>
+                      <a:prstDash val="solid"/>
+                      <a:round/>
+                      <a:headEnd type="none" w="med" len="med"/>
+                      <a:tailEnd type="none" w="med" len="med"/>
+                    </a:lnB>
+                    <a:noFill/>
+                  </a:tcPr>
+                </a:tc>
+                <a:tc>
+                  <a:txBody>
+                    <a:bodyPr/>
+                    <a:lstStyle/>
+                    <a:p>
+                      <a:r>
+                        <a:rPr lang="en-US"/>
+                        <a:t>Sessiya boşaldır</a:t>
+                      </a:r>
+                    </a:p>
+                  </a:txBody>
+                  <a:tcPr anchor="ctr">
+                    <a:lnL w="12700" cap="flat" cmpd="sng" algn="ctr">
+                      <a:solidFill>
+                        <a:schemeClr val="tx1"/>
+                      </a:solidFill>
+                      <a:prstDash val="solid"/>
+                      <a:round/>
+                      <a:headEnd type="none" w="med" len="med"/>
+                      <a:tailEnd type="none" w="med" len="med"/>
+                    </a:lnL>
+                    <a:lnR w="12700" cap="flat" cmpd="sng" algn="ctr">
+                      <a:solidFill>
+                        <a:schemeClr val="tx1"/>
+                      </a:solidFill>
+                      <a:prstDash val="solid"/>
+                      <a:round/>
+                      <a:headEnd type="none" w="med" len="med"/>
+                      <a:tailEnd type="none" w="med" len="med"/>
+                    </a:lnR>
+                    <a:lnT w="12700" cap="flat" cmpd="sng" algn="ctr">
+                      <a:solidFill>
+                        <a:schemeClr val="tx1"/>
+                      </a:solidFill>
+                      <a:prstDash val="solid"/>
+                      <a:round/>
+                      <a:headEnd type="none" w="med" len="med"/>
+                      <a:tailEnd type="none" w="med" len="med"/>
+                    </a:lnT>
+                    <a:lnB w="12700" cap="flat" cmpd="sng" algn="ctr">
+                      <a:solidFill>
+                        <a:schemeClr val="tx1"/>
+                      </a:solidFill>
+                      <a:prstDash val="solid"/>
+                      <a:round/>
+                      <a:headEnd type="none" w="med" len="med"/>
+                      <a:tailEnd type="none" w="med" len="med"/>
+                    </a:lnB>
+                    <a:noFill/>
+                  </a:tcPr>
+                </a:tc>
+                <a:extLst>
+                  <a:ext uri="{0D108BD9-81ED-4DB2-BD59-A6C34878D82A}">
+                    <a16:rowId xmlns:a16="http://schemas.microsoft.com/office/drawing/2014/main" val="3498855470"/>
+                  </a:ext>
+                </a:extLst>
+              </a:tr>
+              <a:tr h="0">
+                <a:tc>
+                  <a:txBody>
+                    <a:bodyPr/>
+                    <a:lstStyle/>
+                    <a:p>
+                      <a:r>
+                        <a:rPr lang="en-US"/>
+                        <a:t>invalidate()</a:t>
+                      </a:r>
+                    </a:p>
+                  </a:txBody>
+                  <a:tcPr anchor="ctr">
+                    <a:lnL w="12700" cap="flat" cmpd="sng" algn="ctr">
+                      <a:solidFill>
+                        <a:schemeClr val="tx1"/>
+                      </a:solidFill>
+                      <a:prstDash val="solid"/>
+                      <a:round/>
+                      <a:headEnd type="none" w="med" len="med"/>
+                      <a:tailEnd type="none" w="med" len="med"/>
+                    </a:lnL>
+                    <a:lnR w="12700" cap="flat" cmpd="sng" algn="ctr">
+                      <a:solidFill>
+                        <a:schemeClr val="tx1"/>
+                      </a:solidFill>
+                      <a:prstDash val="solid"/>
+                      <a:round/>
+                      <a:headEnd type="none" w="med" len="med"/>
+                      <a:tailEnd type="none" w="med" len="med"/>
+                    </a:lnR>
+                    <a:lnT w="12700" cap="flat" cmpd="sng" algn="ctr">
+                      <a:solidFill>
+                        <a:schemeClr val="tx1"/>
+                      </a:solidFill>
+                      <a:prstDash val="solid"/>
+                      <a:round/>
+                      <a:headEnd type="none" w="med" len="med"/>
+                      <a:tailEnd type="none" w="med" len="med"/>
+                    </a:lnT>
+                    <a:lnB w="12700" cap="flat" cmpd="sng" algn="ctr">
+                      <a:solidFill>
+                        <a:schemeClr val="tx1"/>
+                      </a:solidFill>
+                      <a:prstDash val="solid"/>
+                      <a:round/>
+                      <a:headEnd type="none" w="med" len="med"/>
+                      <a:tailEnd type="none" w="med" len="med"/>
+                    </a:lnB>
+                    <a:noFill/>
+                  </a:tcPr>
+                </a:tc>
+                <a:tc>
+                  <a:txBody>
+                    <a:bodyPr/>
+                    <a:lstStyle/>
+                    <a:p>
+                      <a:r>
+                        <a:rPr lang="en-US"/>
+                        <a:t>✅ Bəli</a:t>
+                      </a:r>
+                    </a:p>
+                  </a:txBody>
+                  <a:tcPr anchor="ctr">
+                    <a:lnL w="12700" cap="flat" cmpd="sng" algn="ctr">
+                      <a:solidFill>
+                        <a:schemeClr val="tx1"/>
+                      </a:solidFill>
+                      <a:prstDash val="solid"/>
+                      <a:round/>
+                      <a:headEnd type="none" w="med" len="med"/>
+                      <a:tailEnd type="none" w="med" len="med"/>
+                    </a:lnL>
+                    <a:lnR w="12700" cap="flat" cmpd="sng" algn="ctr">
+                      <a:solidFill>
+                        <a:schemeClr val="tx1"/>
+                      </a:solidFill>
+                      <a:prstDash val="solid"/>
+                      <a:round/>
+                      <a:headEnd type="none" w="med" len="med"/>
+                      <a:tailEnd type="none" w="med" len="med"/>
+                    </a:lnR>
+                    <a:lnT w="12700" cap="flat" cmpd="sng" algn="ctr">
+                      <a:solidFill>
+                        <a:schemeClr val="tx1"/>
+                      </a:solidFill>
+                      <a:prstDash val="solid"/>
+                      <a:round/>
+                      <a:headEnd type="none" w="med" len="med"/>
+                      <a:tailEnd type="none" w="med" len="med"/>
+                    </a:lnT>
+                    <a:lnB w="12700" cap="flat" cmpd="sng" algn="ctr">
+                      <a:solidFill>
+                        <a:schemeClr val="tx1"/>
+                      </a:solidFill>
+                      <a:prstDash val="solid"/>
+                      <a:round/>
+                      <a:headEnd type="none" w="med" len="med"/>
+                      <a:tailEnd type="none" w="med" len="med"/>
+                    </a:lnB>
+                    <a:noFill/>
+                  </a:tcPr>
+                </a:tc>
+                <a:tc>
+                  <a:txBody>
+                    <a:bodyPr/>
+                    <a:lstStyle/>
+                    <a:p>
+                      <a:r>
+                        <a:rPr lang="en-US"/>
+                        <a:t>✅ Bəli</a:t>
+                      </a:r>
+                    </a:p>
+                  </a:txBody>
+                  <a:tcPr anchor="ctr">
+                    <a:lnL w="12700" cap="flat" cmpd="sng" algn="ctr">
+                      <a:solidFill>
+                        <a:schemeClr val="tx1"/>
+                      </a:solidFill>
+                      <a:prstDash val="solid"/>
+                      <a:round/>
+                      <a:headEnd type="none" w="med" len="med"/>
+                      <a:tailEnd type="none" w="med" len="med"/>
+                    </a:lnL>
+                    <a:lnR w="12700" cap="flat" cmpd="sng" algn="ctr">
+                      <a:solidFill>
+                        <a:schemeClr val="tx1"/>
+                      </a:solidFill>
+                      <a:prstDash val="solid"/>
+                      <a:round/>
+                      <a:headEnd type="none" w="med" len="med"/>
+                      <a:tailEnd type="none" w="med" len="med"/>
+                    </a:lnR>
+                    <a:lnT w="12700" cap="flat" cmpd="sng" algn="ctr">
+                      <a:solidFill>
+                        <a:schemeClr val="tx1"/>
+                      </a:solidFill>
+                      <a:prstDash val="solid"/>
+                      <a:round/>
+                      <a:headEnd type="none" w="med" len="med"/>
+                      <a:tailEnd type="none" w="med" len="med"/>
+                    </a:lnT>
+                    <a:lnB w="12700" cap="flat" cmpd="sng" algn="ctr">
+                      <a:solidFill>
+                        <a:schemeClr val="tx1"/>
+                      </a:solidFill>
+                      <a:prstDash val="solid"/>
+                      <a:round/>
+                      <a:headEnd type="none" w="med" len="med"/>
+                      <a:tailEnd type="none" w="med" len="med"/>
+                    </a:lnB>
+                    <a:noFill/>
+                  </a:tcPr>
+                </a:tc>
+                <a:tc>
+                  <a:txBody>
+                    <a:bodyPr/>
+                    <a:lstStyle/>
+                    <a:p>
+                      <a:r>
+                        <a:rPr lang="en-US" b="1"/>
+                        <a:t>Logout</a:t>
+                      </a:r>
+                      <a:r>
+                        <a:rPr lang="en-US"/>
+                        <a:t>, təhlükəsizlik üçün</a:t>
+                      </a:r>
+                    </a:p>
+                  </a:txBody>
+                  <a:tcPr anchor="ctr">
+                    <a:lnL w="12700" cap="flat" cmpd="sng" algn="ctr">
+                      <a:solidFill>
+                        <a:schemeClr val="tx1"/>
+                      </a:solidFill>
+                      <a:prstDash val="solid"/>
+                      <a:round/>
+                      <a:headEnd type="none" w="med" len="med"/>
+                      <a:tailEnd type="none" w="med" len="med"/>
+                    </a:lnL>
+                    <a:lnR w="12700" cap="flat" cmpd="sng" algn="ctr">
+                      <a:solidFill>
+                        <a:schemeClr val="tx1"/>
+                      </a:solidFill>
+                      <a:prstDash val="solid"/>
+                      <a:round/>
+                      <a:headEnd type="none" w="med" len="med"/>
+                      <a:tailEnd type="none" w="med" len="med"/>
+                    </a:lnR>
+                    <a:lnT w="12700" cap="flat" cmpd="sng" algn="ctr">
+                      <a:solidFill>
+                        <a:schemeClr val="tx1"/>
+                      </a:solidFill>
+                      <a:prstDash val="solid"/>
+                      <a:round/>
+                      <a:headEnd type="none" w="med" len="med"/>
+                      <a:tailEnd type="none" w="med" len="med"/>
+                    </a:lnT>
+                    <a:lnB w="12700" cap="flat" cmpd="sng" algn="ctr">
+                      <a:solidFill>
+                        <a:schemeClr val="tx1"/>
+                      </a:solidFill>
+                      <a:prstDash val="solid"/>
+                      <a:round/>
+                      <a:headEnd type="none" w="med" len="med"/>
+                      <a:tailEnd type="none" w="med" len="med"/>
+                    </a:lnB>
+                    <a:noFill/>
+                  </a:tcPr>
+                </a:tc>
+                <a:extLst>
+                  <a:ext uri="{0D108BD9-81ED-4DB2-BD59-A6C34878D82A}">
+                    <a16:rowId xmlns:a16="http://schemas.microsoft.com/office/drawing/2014/main" val="4049928316"/>
+                  </a:ext>
+                </a:extLst>
+              </a:tr>
+            </a:tbl>
+          </a:graphicData>
+        </a:graphic>
+      </p:graphicFrame>
+    </p:spTree>
+    <p:extLst>
+      <p:ext uri="{BB962C8B-B14F-4D97-AF65-F5344CB8AC3E}">
+        <p14:creationId xmlns:p14="http://schemas.microsoft.com/office/powerpoint/2010/main" val="2374345170"/>
+      </p:ext>
+    </p:extLst>
+  </p:cSld>
+  <p:clrMapOvr>
+    <a:masterClrMapping/>
+  </p:clrMapOvr>
+</p:sld>
+</file>
+
+<file path=ppt/slides/slide6.xml><?xml version="1.0" encoding="utf-8"?>
+<p:sld xmlns:a="http://schemas.openxmlformats.org/drawingml/2006/main" xmlns:r="http://schemas.openxmlformats.org/officeDocument/2006/relationships" xmlns:p="http://schemas.openxmlformats.org/presentationml/2006/main">
+  <p:cSld>
+    <p:spTree>
+      <p:nvGrpSpPr>
+        <p:cNvPr id="1" name="">
+          <a:extLst>
+            <a:ext uri="{FF2B5EF4-FFF2-40B4-BE49-F238E27FC236}">
+              <a16:creationId xmlns:a16="http://schemas.microsoft.com/office/drawing/2014/main" id="{0BABC2F2-B432-825F-36C4-2D1B4DB01F2C}"/>
+            </a:ext>
+          </a:extLst>
+        </p:cNvPr>
+        <p:cNvGrpSpPr/>
+        <p:nvPr/>
+      </p:nvGrpSpPr>
+      <p:grpSpPr>
+        <a:xfrm>
+          <a:off x="0" y="0"/>
+          <a:ext cx="0" cy="0"/>
+          <a:chOff x="0" y="0"/>
+          <a:chExt cx="0" cy="0"/>
+        </a:xfrm>
+      </p:grpSpPr>
+      <p:sp>
+        <p:nvSpPr>
+          <p:cNvPr id="3" name="TextBox 2">
+            <a:extLst>
+              <a:ext uri="{FF2B5EF4-FFF2-40B4-BE49-F238E27FC236}">
+                <a16:creationId xmlns:a16="http://schemas.microsoft.com/office/drawing/2014/main" id="{9F9A66CE-1C1F-97A3-24E5-A5AE2B04E12A}"/>
+              </a:ext>
+            </a:extLst>
+          </p:cNvPr>
+          <p:cNvSpPr txBox="1"/>
+          <p:nvPr/>
+        </p:nvSpPr>
+        <p:spPr>
+          <a:xfrm>
+            <a:off x="217714" y="255046"/>
             <a:ext cx="11756571" cy="355354"/>
           </a:xfrm>
           <a:prstGeom prst="rect">
@@ -3551,6 +6980,197 @@
                 <a:effectLst/>
                 <a:latin typeface="Arial" panose="020B0604020202020204" pitchFamily="34" charset="0"/>
               </a:rPr>
+              <a:t>Əgər sən </a:t>
+            </a:r>
+            <a:r>
+              <a:rPr kumimoji="0" lang="en-US" altLang="en-US" sz="1300" b="1" i="0" u="none" strike="noStrike" cap="none" normalizeH="0" baseline="0">
+                <a:ln>
+                  <a:noFill/>
+                </a:ln>
+                <a:solidFill>
+                  <a:schemeClr val="tx1"/>
+                </a:solidFill>
+                <a:effectLst/>
+                <a:latin typeface="Arial" panose="020B0604020202020204" pitchFamily="34" charset="0"/>
+              </a:rPr>
+              <a:t>invalidate() </a:t>
+            </a:r>
+            <a:r>
+              <a:rPr kumimoji="0" lang="en-US" altLang="en-US" sz="1300" b="0" i="0" u="none" strike="noStrike" cap="none" normalizeH="0" baseline="0">
+                <a:ln>
+                  <a:noFill/>
+                </a:ln>
+                <a:solidFill>
+                  <a:schemeClr val="tx1"/>
+                </a:solidFill>
+                <a:effectLst/>
+                <a:latin typeface="Arial" panose="020B0604020202020204" pitchFamily="34" charset="0"/>
+              </a:rPr>
+              <a:t>etsən:</a:t>
+            </a:r>
+            <a:r>
+              <a:rPr kumimoji="0" lang="az-Latn-AZ" altLang="en-US" sz="1300" b="0" i="0" u="none" strike="noStrike" cap="none" normalizeH="0" baseline="0">
+                <a:ln>
+                  <a:noFill/>
+                </a:ln>
+                <a:solidFill>
+                  <a:schemeClr val="tx1"/>
+                </a:solidFill>
+                <a:effectLst/>
+                <a:latin typeface="Arial" panose="020B0604020202020204" pitchFamily="34" charset="0"/>
+              </a:rPr>
+              <a:t> Yeni sessiya </a:t>
+            </a:r>
+            <a:r>
+              <a:rPr kumimoji="0" lang="az-Latn-AZ" altLang="en-US" sz="1300" b="1" i="0" u="none" strike="noStrike" cap="none" normalizeH="0" baseline="0">
+                <a:ln>
+                  <a:noFill/>
+                </a:ln>
+                <a:solidFill>
+                  <a:schemeClr val="tx1"/>
+                </a:solidFill>
+                <a:effectLst/>
+                <a:latin typeface="Arial" panose="020B0604020202020204" pitchFamily="34" charset="0"/>
+              </a:rPr>
+              <a:t>ID</a:t>
+            </a:r>
+            <a:r>
+              <a:rPr kumimoji="0" lang="az-Latn-AZ" altLang="en-US" sz="1300" b="0" i="0" u="none" strike="noStrike" cap="none" normalizeH="0" baseline="0">
+                <a:ln>
+                  <a:noFill/>
+                </a:ln>
+                <a:solidFill>
+                  <a:schemeClr val="tx1"/>
+                </a:solidFill>
+                <a:effectLst/>
+                <a:latin typeface="Arial" panose="020B0604020202020204" pitchFamily="34" charset="0"/>
+              </a:rPr>
+              <a:t> yaradılır  və hücum riski tam aradan qalxır.</a:t>
+            </a:r>
+            <a:endParaRPr kumimoji="0" lang="en-US" altLang="en-US" sz="1300" b="0" i="0" u="none" strike="noStrike" cap="none" normalizeH="0" baseline="0">
+              <a:ln>
+                <a:noFill/>
+              </a:ln>
+              <a:solidFill>
+                <a:schemeClr val="tx1"/>
+              </a:solidFill>
+              <a:effectLst/>
+              <a:latin typeface="Arial" panose="020B0604020202020204" pitchFamily="34" charset="0"/>
+            </a:endParaRPr>
+          </a:p>
+        </p:txBody>
+      </p:sp>
+      <p:pic>
+        <p:nvPicPr>
+          <p:cNvPr id="4" name="Picture 3">
+            <a:extLst>
+              <a:ext uri="{FF2B5EF4-FFF2-40B4-BE49-F238E27FC236}">
+                <a16:creationId xmlns:a16="http://schemas.microsoft.com/office/drawing/2014/main" id="{DD336F79-CA79-EBB2-B464-04F75DA2C859}"/>
+              </a:ext>
+            </a:extLst>
+          </p:cNvPr>
+          <p:cNvPicPr>
+            <a:picLocks noChangeAspect="1"/>
+          </p:cNvPicPr>
+          <p:nvPr/>
+        </p:nvPicPr>
+        <p:blipFill>
+          <a:blip r:embed="rId2"/>
+          <a:stretch>
+            <a:fillRect/>
+          </a:stretch>
+        </p:blipFill>
+        <p:spPr>
+          <a:xfrm>
+            <a:off x="217714" y="1103821"/>
+            <a:ext cx="5658640" cy="2086266"/>
+          </a:xfrm>
+          <a:prstGeom prst="rect">
+            <a:avLst/>
+          </a:prstGeom>
+        </p:spPr>
+      </p:pic>
+    </p:spTree>
+    <p:extLst>
+      <p:ext uri="{BB962C8B-B14F-4D97-AF65-F5344CB8AC3E}">
+        <p14:creationId xmlns:p14="http://schemas.microsoft.com/office/powerpoint/2010/main" val="1458671677"/>
+      </p:ext>
+    </p:extLst>
+  </p:cSld>
+  <p:clrMapOvr>
+    <a:masterClrMapping/>
+  </p:clrMapOvr>
+</p:sld>
+</file>
+
+<file path=ppt/slides/slide7.xml><?xml version="1.0" encoding="utf-8"?>
+<p:sld xmlns:a="http://schemas.openxmlformats.org/drawingml/2006/main" xmlns:r="http://schemas.openxmlformats.org/officeDocument/2006/relationships" xmlns:p="http://schemas.openxmlformats.org/presentationml/2006/main">
+  <p:cSld>
+    <p:spTree>
+      <p:nvGrpSpPr>
+        <p:cNvPr id="1" name="">
+          <a:extLst>
+            <a:ext uri="{FF2B5EF4-FFF2-40B4-BE49-F238E27FC236}">
+              <a16:creationId xmlns:a16="http://schemas.microsoft.com/office/drawing/2014/main" id="{32094A01-25F3-F2F6-A8AF-2EB902406209}"/>
+            </a:ext>
+          </a:extLst>
+        </p:cNvPr>
+        <p:cNvGrpSpPr/>
+        <p:nvPr/>
+      </p:nvGrpSpPr>
+      <p:grpSpPr>
+        <a:xfrm>
+          <a:off x="0" y="0"/>
+          <a:ext cx="0" cy="0"/>
+          <a:chOff x="0" y="0"/>
+          <a:chExt cx="0" cy="0"/>
+        </a:xfrm>
+      </p:grpSpPr>
+      <p:sp>
+        <p:nvSpPr>
+          <p:cNvPr id="3" name="TextBox 2">
+            <a:extLst>
+              <a:ext uri="{FF2B5EF4-FFF2-40B4-BE49-F238E27FC236}">
+                <a16:creationId xmlns:a16="http://schemas.microsoft.com/office/drawing/2014/main" id="{0B4C8206-0799-0378-0292-C2A7C88E2A32}"/>
+              </a:ext>
+            </a:extLst>
+          </p:cNvPr>
+          <p:cNvSpPr txBox="1"/>
+          <p:nvPr/>
+        </p:nvSpPr>
+        <p:spPr>
+          <a:xfrm>
+            <a:off x="217714" y="255046"/>
+            <a:ext cx="11756571" cy="355354"/>
+          </a:xfrm>
+          <a:prstGeom prst="rect">
+            <a:avLst/>
+          </a:prstGeom>
+          <a:noFill/>
+        </p:spPr>
+        <p:txBody>
+          <a:bodyPr wrap="square">
+            <a:spAutoFit/>
+          </a:bodyPr>
+          <a:lstStyle/>
+          <a:p>
+            <a:pPr>
+              <a:lnSpc>
+                <a:spcPct val="150000"/>
+              </a:lnSpc>
+              <a:buNone/>
+            </a:pPr>
+            <a:r>
+              <a:rPr kumimoji="0" lang="en-US" altLang="en-US" sz="1300" b="0" i="0" u="none" strike="noStrike" cap="none" normalizeH="0" baseline="0">
+                <a:ln>
+                  <a:noFill/>
+                </a:ln>
+                <a:solidFill>
+                  <a:schemeClr val="tx1"/>
+                </a:solidFill>
+                <a:effectLst/>
+                <a:latin typeface="Arial" panose="020B0604020202020204" pitchFamily="34" charset="0"/>
+              </a:rPr>
               <a:t>.</a:t>
             </a:r>
           </a:p>
@@ -3559,7 +7179,93 @@
     </p:spTree>
     <p:extLst>
       <p:ext uri="{BB962C8B-B14F-4D97-AF65-F5344CB8AC3E}">
-        <p14:creationId xmlns:p14="http://schemas.microsoft.com/office/powerpoint/2010/main" val="3095838342"/>
+        <p14:creationId xmlns:p14="http://schemas.microsoft.com/office/powerpoint/2010/main" val="4024408129"/>
+      </p:ext>
+    </p:extLst>
+  </p:cSld>
+  <p:clrMapOvr>
+    <a:masterClrMapping/>
+  </p:clrMapOvr>
+</p:sld>
+</file>
+
+<file path=ppt/slides/slide8.xml><?xml version="1.0" encoding="utf-8"?>
+<p:sld xmlns:a="http://schemas.openxmlformats.org/drawingml/2006/main" xmlns:r="http://schemas.openxmlformats.org/officeDocument/2006/relationships" xmlns:p="http://schemas.openxmlformats.org/presentationml/2006/main">
+  <p:cSld>
+    <p:spTree>
+      <p:nvGrpSpPr>
+        <p:cNvPr id="1" name="">
+          <a:extLst>
+            <a:ext uri="{FF2B5EF4-FFF2-40B4-BE49-F238E27FC236}">
+              <a16:creationId xmlns:a16="http://schemas.microsoft.com/office/drawing/2014/main" id="{C48F785C-BB21-2628-2147-37A96B9F1A27}"/>
+            </a:ext>
+          </a:extLst>
+        </p:cNvPr>
+        <p:cNvGrpSpPr/>
+        <p:nvPr/>
+      </p:nvGrpSpPr>
+      <p:grpSpPr>
+        <a:xfrm>
+          <a:off x="0" y="0"/>
+          <a:ext cx="0" cy="0"/>
+          <a:chOff x="0" y="0"/>
+          <a:chExt cx="0" cy="0"/>
+        </a:xfrm>
+      </p:grpSpPr>
+      <p:sp>
+        <p:nvSpPr>
+          <p:cNvPr id="3" name="TextBox 2">
+            <a:extLst>
+              <a:ext uri="{FF2B5EF4-FFF2-40B4-BE49-F238E27FC236}">
+                <a16:creationId xmlns:a16="http://schemas.microsoft.com/office/drawing/2014/main" id="{5709CE23-E89A-E6D3-F30A-F96A621BADE0}"/>
+              </a:ext>
+            </a:extLst>
+          </p:cNvPr>
+          <p:cNvSpPr txBox="1"/>
+          <p:nvPr/>
+        </p:nvSpPr>
+        <p:spPr>
+          <a:xfrm>
+            <a:off x="217714" y="255046"/>
+            <a:ext cx="11756571" cy="355354"/>
+          </a:xfrm>
+          <a:prstGeom prst="rect">
+            <a:avLst/>
+          </a:prstGeom>
+          <a:noFill/>
+        </p:spPr>
+        <p:txBody>
+          <a:bodyPr wrap="square">
+            <a:spAutoFit/>
+          </a:bodyPr>
+          <a:lstStyle/>
+          <a:p>
+            <a:pPr>
+              <a:lnSpc>
+                <a:spcPct val="150000"/>
+              </a:lnSpc>
+              <a:buNone/>
+            </a:pPr>
+            <a:r>
+              <a:rPr kumimoji="0" lang="en-US" altLang="en-US" sz="1300" b="0" i="0" u="none" strike="noStrike" cap="none" normalizeH="0" baseline="0">
+                <a:ln>
+                  <a:noFill/>
+                </a:ln>
+                <a:solidFill>
+                  <a:schemeClr val="tx1"/>
+                </a:solidFill>
+                <a:effectLst/>
+                <a:latin typeface="Arial" panose="020B0604020202020204" pitchFamily="34" charset="0"/>
+              </a:rPr>
+              <a:t>.</a:t>
+            </a:r>
+          </a:p>
+        </p:txBody>
+      </p:sp>
+    </p:spTree>
+    <p:extLst>
+      <p:ext uri="{BB962C8B-B14F-4D97-AF65-F5344CB8AC3E}">
+        <p14:creationId xmlns:p14="http://schemas.microsoft.com/office/powerpoint/2010/main" val="242010966"/>
       </p:ext>
     </p:extLst>
   </p:cSld>

</xml_diff>